<commit_message>
Add kernel-launch-flow and warp-divergence diagrams
- Session 1: kernel launch flow — host <<<>>> call -> GPU scheduler
  distributes blocks to SMs -> warps execute -> done, with an async note
  panel (host returns immediately; sync to use results)
- Session 3: warp divergence — a warp hitting if/else runs both paths
  serially (A-path then B-path, others masked/waiting), with the cost and
  how to avoid it; notes that this repo's guard-only branches stay near-uniform

Fixed an undefined RED color constant in the Session 3 generator (added to
its palette). All six decks rebuilt clean and pass the pptx schema check;
new diagrams verified for bounds/overlap via the geometry render. README
counts updated (S1 15, S3 13).

Co-Authored-By: Claude Opus 4.8 <noreply@anthropic.com>
Claude-Session: https://claude.ai/code/session_01AK6CoJaDASHVRpPc4M39gP
</commit_message>
<xml_diff>
--- a/seminar/slides/세션1_CUDA_스레드모델과_첫커널.pptx
+++ b/seminar/slides/세션1_CUDA_스레드모델과_첫커널.pptx
@@ -19,9 +19,10 @@
     <p:sldId id="267" r:id="rId13"/>
     <p:sldId id="268" r:id="rId14"/>
     <p:sldId id="269" r:id="rId15"/>
+    <p:sldId id="270" r:id="rId16"/>
   </p:sldIdLst>
   <p:notesMasterIdLst>
-    <p:notesMasterId r:id="rId16"/>
+    <p:notesMasterId r:id="rId17"/>
   </p:notesMasterIdLst>
   <p:sldSz cx="12192000" cy="6858000"/>
   <p:notesSz cx="6858000" cy="12192000"/>
@@ -779,7 +780,7 @@
           <a:p>
             <a:r>
               <a:rPr lang="en-US" dirty="0"/>
-              <a:t>실습 랩 문서(세션1_실습랩.md)를 나눠주고 진행합니다. Ex 4는 반드시 원복하도록 강조하세요.</a:t>
+              <a:t>launch = CPU 한 줄 → GPU가 블록을 SM에 분배 → 워프 실행 → 완료. 호스트는 비동기로 리턴한다는 점이 다음 세션들의 복선.</a:t>
             </a:r>
             <a:endParaRPr lang="en-US" dirty="0"/>
           </a:p>
@@ -867,7 +868,7 @@
           <a:p>
             <a:r>
               <a:rPr lang="en-US" dirty="0"/>
-              <a:t>네 가지 목표(슬라이드 2)로 돌아가 자가 점검을 유도하세요.</a:t>
+              <a:t>실습 랩 문서(세션1_실습랩.md)를 나눠주고 진행합니다. Ex 4는 반드시 원복하도록 강조하세요.</a:t>
             </a:r>
             <a:endParaRPr lang="en-US" dirty="0"/>
           </a:p>
@@ -955,7 +956,7 @@
           <a:p>
             <a:r>
               <a:rPr lang="en-US" dirty="0"/>
-              <a:t>오늘의 write 커널이 다음 세션 read 커널로 이어진다는 연속성을 강조하며 마무리하세요.</a:t>
+              <a:t>네 가지 목표(슬라이드 2)로 돌아가 자가 점검을 유도하세요.</a:t>
             </a:r>
             <a:endParaRPr lang="en-US" dirty="0"/>
           </a:p>
@@ -979,6 +980,94 @@
             <a:fld id="{F7021451-1387-4CA6-816F-3879F97B5CBC}" type="slidenum">
               <a:rPr lang="en-US"/>
               <a:t>14</a:t>
+            </a:fld>
+            <a:endParaRPr lang="en-US"/>
+          </a:p>
+        </p:txBody>
+      </p:sp>
+    </p:spTree>
+    <p:extLst>
+      <p:ext uri="{BB962C8B-B14F-4D97-AF65-F5344CB8AC3E}">
+        <p14:creationId xmlns:p14="http://schemas.microsoft.com/office/powerpoint/2010/main" val="1024086991"/>
+      </p:ext>
+    </p:extLst>
+  </p:cSld>
+  <p:clrMapOvr>
+    <a:masterClrMapping/>
+  </p:clrMapOvr>
+</p:notes>
+</file>
+
+<file path=ppt/notesSlides/notesSlide15.xml><?xml version="1.0" encoding="utf-8"?>
+<p:notes xmlns:a="http://schemas.openxmlformats.org/drawingml/2006/main" xmlns:r="http://schemas.openxmlformats.org/officeDocument/2006/relationships" xmlns:p="http://schemas.openxmlformats.org/presentationml/2006/main">
+  <p:cSld>
+    <p:spTree>
+      <p:nvGrpSpPr>
+        <p:cNvPr id="1" name=""/>
+        <p:cNvGrpSpPr/>
+        <p:nvPr/>
+      </p:nvGrpSpPr>
+      <p:grpSpPr>
+        <a:xfrm>
+          <a:off x="0" y="0"/>
+          <a:ext cx="0" cy="0"/>
+          <a:chOff x="0" y="0"/>
+          <a:chExt cx="0" cy="0"/>
+        </a:xfrm>
+      </p:grpSpPr>
+      <p:sp>
+        <p:nvSpPr>
+          <p:cNvPr id="2" name="Slide Image Placeholder 1"/>
+          <p:cNvSpPr>
+            <a:spLocks noGrp="1" noRot="1" noChangeAspect="1"/>
+          </p:cNvSpPr>
+          <p:nvPr>
+            <p:ph type="sldImg"/>
+          </p:nvPr>
+        </p:nvSpPr>
+        <p:spPr/>
+      </p:sp>
+      <p:sp>
+        <p:nvSpPr>
+          <p:cNvPr id="3" name="Notes Placeholder 2"/>
+          <p:cNvSpPr>
+            <a:spLocks noGrp="1"/>
+          </p:cNvSpPr>
+          <p:nvPr>
+            <p:ph type="body" idx="1"/>
+          </p:nvPr>
+        </p:nvSpPr>
+        <p:spPr/>
+        <p:txBody>
+          <a:bodyPr/>
+          <a:lstStyle/>
+          <a:p>
+            <a:r>
+              <a:rPr lang="en-US" dirty="0"/>
+              <a:t>오늘의 write 커널이 다음 세션 read 커널로 이어진다는 연속성을 강조하며 마무리하세요.</a:t>
+            </a:r>
+            <a:endParaRPr lang="en-US" dirty="0"/>
+          </a:p>
+        </p:txBody>
+      </p:sp>
+      <p:sp>
+        <p:nvSpPr>
+          <p:cNvPr id="4" name="Slide Number Placeholder 3"/>
+          <p:cNvSpPr>
+            <a:spLocks noGrp="1"/>
+          </p:cNvSpPr>
+          <p:nvPr>
+            <p:ph type="sldNum" sz="quarter" idx="10"/>
+          </p:nvPr>
+        </p:nvSpPr>
+        <p:spPr/>
+        <p:txBody>
+          <a:bodyPr/>
+          <a:lstStyle/>
+          <a:p>
+            <a:fld id="{F7021451-1387-4CA6-816F-3879F97B5CBC}" type="slidenum">
+              <a:rPr lang="en-US"/>
+              <a:t>15</a:t>
             </a:fld>
             <a:endParaRPr lang="en-US"/>
           </a:p>
@@ -3194,7 +3283,7 @@
                 <a:ea typeface="Courier New" pitchFamily="34" charset="-122"/>
                 <a:cs typeface="Courier New" pitchFamily="34" charset="-120"/>
               </a:rPr>
-              <a:t>10</a:t>
+              <a:t>9</a:t>
             </a:r>
             <a:endParaRPr lang="en-US" sz="2200" dirty="0"/>
           </a:p>
@@ -3233,7 +3322,7 @@
                 <a:ea typeface="Malgun Gothic" pitchFamily="34" charset="-122"/>
                 <a:cs typeface="Malgun Gothic" pitchFamily="34" charset="-120"/>
               </a:rPr>
-              <a:t>실습 미리보기 · Lab 1</a:t>
+              <a:t>커널 launch 흐름 · 호출에서 완료까지</a:t>
             </a:r>
             <a:endParaRPr lang="en-US" sz="3000" dirty="0"/>
           </a:p>
@@ -3241,64 +3330,713 @@
       </p:sp>
       <p:sp>
         <p:nvSpPr>
-          <p:cNvPr id="4" name="Shape 2"/>
-          <p:cNvSpPr/>
-          <p:nvPr/>
-        </p:nvSpPr>
-        <p:spPr>
-          <a:xfrm>
-            <a:off x="548640" y="1554480"/>
-            <a:ext cx="5303520" cy="1965960"/>
+          <p:cNvPr id="4" name="Text 2"/>
+          <p:cNvSpPr/>
+          <p:nvPr/>
+        </p:nvSpPr>
+        <p:spPr>
+          <a:xfrm>
+            <a:off x="548640" y="1371600"/>
+            <a:ext cx="11064240" cy="411480"/>
+          </a:xfrm>
+          <a:prstGeom prst="rect">
+            <a:avLst/>
+          </a:prstGeom>
+          <a:noFill/>
+          <a:ln/>
+        </p:spPr>
+        <p:txBody>
+          <a:bodyPr wrap="square" lIns="0" tIns="0" rIns="0" bIns="0" rtlCol="0" anchor="ctr"/>
+          <a:lstStyle/>
+          <a:p>
+            <a:pPr indent="0" marL="0">
+              <a:buNone/>
+            </a:pPr>
+            <a:r>
+              <a:rPr lang="en-US" sz="1500" dirty="0">
+                <a:solidFill>
+                  <a:srgbClr val="9AA6B2"/>
+                </a:solidFill>
+                <a:latin typeface="Malgun Gothic" pitchFamily="34" charset="0"/>
+                <a:ea typeface="Malgun Gothic" pitchFamily="34" charset="-122"/>
+                <a:cs typeface="Malgun Gothic" pitchFamily="34" charset="-120"/>
+              </a:rPr>
+              <a:t>&lt;&lt;&lt;&gt;&gt;&gt; 한 줄을 실행하면, 요청이 GPU로 넘어가 블록이 SM에 분배되고 워프 단위로 실행됩니다.</a:t>
+            </a:r>
+            <a:endParaRPr lang="en-US" sz="1500" dirty="0"/>
+          </a:p>
+        </p:txBody>
+      </p:sp>
+      <p:sp>
+        <p:nvSpPr>
+          <p:cNvPr id="5" name="Shape 3"/>
+          <p:cNvSpPr/>
+          <p:nvPr/>
+        </p:nvSpPr>
+        <p:spPr>
+          <a:xfrm>
+            <a:off x="548640" y="1920240"/>
+            <a:ext cx="6949440" cy="822960"/>
           </a:xfrm>
           <a:prstGeom prst="roundRect">
             <a:avLst>
-              <a:gd name="adj" fmla="val 3721"/>
+              <a:gd name="adj" fmla="val 6667"/>
+            </a:avLst>
+          </a:prstGeom>
+          <a:solidFill>
+            <a:srgbClr val="16242C"/>
+          </a:solidFill>
+          <a:ln w="19050">
+            <a:solidFill>
+              <a:srgbClr val="4FB0C6"/>
+            </a:solidFill>
+            <a:prstDash val="solid"/>
+          </a:ln>
+        </p:spPr>
+      </p:sp>
+      <p:sp>
+        <p:nvSpPr>
+          <p:cNvPr id="6" name="Text 4"/>
+          <p:cNvSpPr/>
+          <p:nvPr/>
+        </p:nvSpPr>
+        <p:spPr>
+          <a:xfrm>
+            <a:off x="804672" y="2029968"/>
+            <a:ext cx="6492240" cy="365760"/>
+          </a:xfrm>
+          <a:prstGeom prst="rect">
+            <a:avLst/>
+          </a:prstGeom>
+          <a:noFill/>
+          <a:ln/>
+        </p:spPr>
+        <p:txBody>
+          <a:bodyPr wrap="square" lIns="0" tIns="0" rIns="0" bIns="0" rtlCol="0" anchor="ctr"/>
+          <a:lstStyle/>
+          <a:p>
+            <a:pPr indent="0" marL="0">
+              <a:buNone/>
+            </a:pPr>
+            <a:r>
+              <a:rPr lang="en-US" sz="1500" b="1" dirty="0">
+                <a:solidFill>
+                  <a:srgbClr val="4FB0C6"/>
+                </a:solidFill>
+                <a:latin typeface="Malgun Gothic" pitchFamily="34" charset="0"/>
+                <a:ea typeface="Malgun Gothic" pitchFamily="34" charset="-122"/>
+                <a:cs typeface="Malgun Gothic" pitchFamily="34" charset="-120"/>
+              </a:rPr>
+              <a:t>① 호스트(CPU) — 커널 실행 요청</a:t>
+            </a:r>
+            <a:endParaRPr lang="en-US" sz="1500" dirty="0"/>
+          </a:p>
+        </p:txBody>
+      </p:sp>
+      <p:sp>
+        <p:nvSpPr>
+          <p:cNvPr id="7" name="Text 5"/>
+          <p:cNvSpPr/>
+          <p:nvPr/>
+        </p:nvSpPr>
+        <p:spPr>
+          <a:xfrm>
+            <a:off x="804672" y="2377440"/>
+            <a:ext cx="6492240" cy="292608"/>
+          </a:xfrm>
+          <a:prstGeom prst="rect">
+            <a:avLst/>
+          </a:prstGeom>
+          <a:noFill/>
+          <a:ln/>
+        </p:spPr>
+        <p:txBody>
+          <a:bodyPr wrap="square" lIns="0" tIns="0" rIns="0" bIns="0" rtlCol="0" anchor="ctr"/>
+          <a:lstStyle/>
+          <a:p>
+            <a:pPr indent="0" marL="0">
+              <a:buNone/>
+            </a:pPr>
+            <a:r>
+              <a:rPr lang="en-US" sz="1150" dirty="0">
+                <a:solidFill>
+                  <a:srgbClr val="9AA6B2"/>
+                </a:solidFill>
+                <a:latin typeface="Courier New" pitchFamily="34" charset="0"/>
+                <a:ea typeface="Courier New" pitchFamily="34" charset="-122"/>
+                <a:cs typeface="Courier New" pitchFamily="34" charset="-120"/>
+              </a:rPr>
+              <a:t>kernel_move_inv_write&lt;&lt;&lt;128, 1&gt;&gt;&gt;(...)</a:t>
+            </a:r>
+            <a:endParaRPr lang="en-US" sz="1150" dirty="0"/>
+          </a:p>
+        </p:txBody>
+      </p:sp>
+      <p:sp>
+        <p:nvSpPr>
+          <p:cNvPr id="8" name="Shape 6"/>
+          <p:cNvSpPr/>
+          <p:nvPr/>
+        </p:nvSpPr>
+        <p:spPr>
+          <a:xfrm>
+            <a:off x="4023360" y="2761488"/>
+            <a:ext cx="0" cy="173736"/>
+          </a:xfrm>
+          <a:prstGeom prst="line">
+            <a:avLst/>
+          </a:prstGeom>
+          <a:noFill/>
+          <a:ln w="25400">
+            <a:solidFill>
+              <a:srgbClr val="9AA6B2"/>
+            </a:solidFill>
+            <a:prstDash val="solid"/>
+            <a:tailEnd type="triangle"/>
+          </a:ln>
+        </p:spPr>
+      </p:sp>
+      <p:sp>
+        <p:nvSpPr>
+          <p:cNvPr id="9" name="Shape 7"/>
+          <p:cNvSpPr/>
+          <p:nvPr/>
+        </p:nvSpPr>
+        <p:spPr>
+          <a:xfrm>
+            <a:off x="548640" y="2953512"/>
+            <a:ext cx="6949440" cy="822960"/>
+          </a:xfrm>
+          <a:prstGeom prst="roundRect">
+            <a:avLst>
+              <a:gd name="adj" fmla="val 6667"/>
+            </a:avLst>
+          </a:prstGeom>
+          <a:solidFill>
+            <a:srgbClr val="16241A"/>
+          </a:solidFill>
+          <a:ln w="19050">
+            <a:solidFill>
+              <a:srgbClr val="8CC63F"/>
+            </a:solidFill>
+            <a:prstDash val="solid"/>
+          </a:ln>
+        </p:spPr>
+      </p:sp>
+      <p:sp>
+        <p:nvSpPr>
+          <p:cNvPr id="10" name="Text 8"/>
+          <p:cNvSpPr/>
+          <p:nvPr/>
+        </p:nvSpPr>
+        <p:spPr>
+          <a:xfrm>
+            <a:off x="804672" y="3063240"/>
+            <a:ext cx="6492240" cy="365760"/>
+          </a:xfrm>
+          <a:prstGeom prst="rect">
+            <a:avLst/>
+          </a:prstGeom>
+          <a:noFill/>
+          <a:ln/>
+        </p:spPr>
+        <p:txBody>
+          <a:bodyPr wrap="square" lIns="0" tIns="0" rIns="0" bIns="0" rtlCol="0" anchor="ctr"/>
+          <a:lstStyle/>
+          <a:p>
+            <a:pPr indent="0" marL="0">
+              <a:buNone/>
+            </a:pPr>
+            <a:r>
+              <a:rPr lang="en-US" sz="1500" b="1" dirty="0">
+                <a:solidFill>
+                  <a:srgbClr val="8CC63F"/>
+                </a:solidFill>
+                <a:latin typeface="Malgun Gothic" pitchFamily="34" charset="0"/>
+                <a:ea typeface="Malgun Gothic" pitchFamily="34" charset="-122"/>
+                <a:cs typeface="Malgun Gothic" pitchFamily="34" charset="-120"/>
+              </a:rPr>
+              <a:t>② GPU 스케줄러 — 블록을 SM에 분배</a:t>
+            </a:r>
+            <a:endParaRPr lang="en-US" sz="1500" dirty="0"/>
+          </a:p>
+        </p:txBody>
+      </p:sp>
+      <p:sp>
+        <p:nvSpPr>
+          <p:cNvPr id="11" name="Text 9"/>
+          <p:cNvSpPr/>
+          <p:nvPr/>
+        </p:nvSpPr>
+        <p:spPr>
+          <a:xfrm>
+            <a:off x="804672" y="3410712"/>
+            <a:ext cx="6492240" cy="292608"/>
+          </a:xfrm>
+          <a:prstGeom prst="rect">
+            <a:avLst/>
+          </a:prstGeom>
+          <a:noFill/>
+          <a:ln/>
+        </p:spPr>
+        <p:txBody>
+          <a:bodyPr wrap="square" lIns="0" tIns="0" rIns="0" bIns="0" rtlCol="0" anchor="ctr"/>
+          <a:lstStyle/>
+          <a:p>
+            <a:pPr indent="0" marL="0">
+              <a:buNone/>
+            </a:pPr>
+            <a:r>
+              <a:rPr lang="en-US" sz="1150" dirty="0">
+                <a:solidFill>
+                  <a:srgbClr val="9AA6B2"/>
+                </a:solidFill>
+                <a:latin typeface="Courier New" pitchFamily="34" charset="0"/>
+                <a:ea typeface="Courier New" pitchFamily="34" charset="-122"/>
+                <a:cs typeface="Courier New" pitchFamily="34" charset="-120"/>
+              </a:rPr>
+              <a:t>128개 블록 → 여러 SM에 나눠 배정</a:t>
+            </a:r>
+            <a:endParaRPr lang="en-US" sz="1150" dirty="0"/>
+          </a:p>
+        </p:txBody>
+      </p:sp>
+      <p:sp>
+        <p:nvSpPr>
+          <p:cNvPr id="12" name="Shape 10"/>
+          <p:cNvSpPr/>
+          <p:nvPr/>
+        </p:nvSpPr>
+        <p:spPr>
+          <a:xfrm>
+            <a:off x="4023360" y="3794760"/>
+            <a:ext cx="0" cy="173736"/>
+          </a:xfrm>
+          <a:prstGeom prst="line">
+            <a:avLst/>
+          </a:prstGeom>
+          <a:noFill/>
+          <a:ln w="25400">
+            <a:solidFill>
+              <a:srgbClr val="9AA6B2"/>
+            </a:solidFill>
+            <a:prstDash val="solid"/>
+            <a:tailEnd type="triangle"/>
+          </a:ln>
+        </p:spPr>
+      </p:sp>
+      <p:sp>
+        <p:nvSpPr>
+          <p:cNvPr id="13" name="Shape 11"/>
+          <p:cNvSpPr/>
+          <p:nvPr/>
+        </p:nvSpPr>
+        <p:spPr>
+          <a:xfrm>
+            <a:off x="548640" y="3986784"/>
+            <a:ext cx="6949440" cy="822960"/>
+          </a:xfrm>
+          <a:prstGeom prst="roundRect">
+            <a:avLst>
+              <a:gd name="adj" fmla="val 6667"/>
+            </a:avLst>
+          </a:prstGeom>
+          <a:solidFill>
+            <a:srgbClr val="16241A"/>
+          </a:solidFill>
+          <a:ln w="19050">
+            <a:solidFill>
+              <a:srgbClr val="8CC63F"/>
+            </a:solidFill>
+            <a:prstDash val="solid"/>
+          </a:ln>
+        </p:spPr>
+      </p:sp>
+      <p:sp>
+        <p:nvSpPr>
+          <p:cNvPr id="14" name="Text 12"/>
+          <p:cNvSpPr/>
+          <p:nvPr/>
+        </p:nvSpPr>
+        <p:spPr>
+          <a:xfrm>
+            <a:off x="804672" y="4096512"/>
+            <a:ext cx="6492240" cy="365760"/>
+          </a:xfrm>
+          <a:prstGeom prst="rect">
+            <a:avLst/>
+          </a:prstGeom>
+          <a:noFill/>
+          <a:ln/>
+        </p:spPr>
+        <p:txBody>
+          <a:bodyPr wrap="square" lIns="0" tIns="0" rIns="0" bIns="0" rtlCol="0" anchor="ctr"/>
+          <a:lstStyle/>
+          <a:p>
+            <a:pPr indent="0" marL="0">
+              <a:buNone/>
+            </a:pPr>
+            <a:r>
+              <a:rPr lang="en-US" sz="1500" b="1" dirty="0">
+                <a:solidFill>
+                  <a:srgbClr val="8CC63F"/>
+                </a:solidFill>
+                <a:latin typeface="Malgun Gothic" pitchFamily="34" charset="0"/>
+                <a:ea typeface="Malgun Gothic" pitchFamily="34" charset="-122"/>
+                <a:cs typeface="Malgun Gothic" pitchFamily="34" charset="-120"/>
+              </a:rPr>
+              <a:t>③ 각 SM — 워프(32 스레드) 단위로 실행</a:t>
+            </a:r>
+            <a:endParaRPr lang="en-US" sz="1500" dirty="0"/>
+          </a:p>
+        </p:txBody>
+      </p:sp>
+      <p:sp>
+        <p:nvSpPr>
+          <p:cNvPr id="15" name="Text 13"/>
+          <p:cNvSpPr/>
+          <p:nvPr/>
+        </p:nvSpPr>
+        <p:spPr>
+          <a:xfrm>
+            <a:off x="804672" y="4443984"/>
+            <a:ext cx="6492240" cy="292608"/>
+          </a:xfrm>
+          <a:prstGeom prst="rect">
+            <a:avLst/>
+          </a:prstGeom>
+          <a:noFill/>
+          <a:ln/>
+        </p:spPr>
+        <p:txBody>
+          <a:bodyPr wrap="square" lIns="0" tIns="0" rIns="0" bIns="0" rtlCol="0" anchor="ctr"/>
+          <a:lstStyle/>
+          <a:p>
+            <a:pPr indent="0" marL="0">
+              <a:buNone/>
+            </a:pPr>
+            <a:r>
+              <a:rPr lang="en-US" sz="1150" dirty="0">
+                <a:solidFill>
+                  <a:srgbClr val="9AA6B2"/>
+                </a:solidFill>
+                <a:latin typeface="Courier New" pitchFamily="34" charset="0"/>
+                <a:ea typeface="Courier New" pitchFamily="34" charset="-122"/>
+                <a:cs typeface="Courier New" pitchFamily="34" charset="-120"/>
+              </a:rPr>
+              <a:t>블록 안 스레드들이 실제 연산 수행</a:t>
+            </a:r>
+            <a:endParaRPr lang="en-US" sz="1150" dirty="0"/>
+          </a:p>
+        </p:txBody>
+      </p:sp>
+      <p:sp>
+        <p:nvSpPr>
+          <p:cNvPr id="16" name="Shape 14"/>
+          <p:cNvSpPr/>
+          <p:nvPr/>
+        </p:nvSpPr>
+        <p:spPr>
+          <a:xfrm>
+            <a:off x="4023360" y="4828032"/>
+            <a:ext cx="0" cy="173736"/>
+          </a:xfrm>
+          <a:prstGeom prst="line">
+            <a:avLst/>
+          </a:prstGeom>
+          <a:noFill/>
+          <a:ln w="25400">
+            <a:solidFill>
+              <a:srgbClr val="9AA6B2"/>
+            </a:solidFill>
+            <a:prstDash val="solid"/>
+            <a:tailEnd type="triangle"/>
+          </a:ln>
+        </p:spPr>
+      </p:sp>
+      <p:sp>
+        <p:nvSpPr>
+          <p:cNvPr id="17" name="Shape 15"/>
+          <p:cNvSpPr/>
+          <p:nvPr/>
+        </p:nvSpPr>
+        <p:spPr>
+          <a:xfrm>
+            <a:off x="548640" y="5020056"/>
+            <a:ext cx="6949440" cy="822960"/>
+          </a:xfrm>
+          <a:prstGeom prst="roundRect">
+            <a:avLst>
+              <a:gd name="adj" fmla="val 6667"/>
+            </a:avLst>
+          </a:prstGeom>
+          <a:solidFill>
+            <a:srgbClr val="16241A"/>
+          </a:solidFill>
+          <a:ln w="19050">
+            <a:solidFill>
+              <a:srgbClr val="8CC63F"/>
+            </a:solidFill>
+            <a:prstDash val="solid"/>
+          </a:ln>
+        </p:spPr>
+      </p:sp>
+      <p:sp>
+        <p:nvSpPr>
+          <p:cNvPr id="18" name="Text 16"/>
+          <p:cNvSpPr/>
+          <p:nvPr/>
+        </p:nvSpPr>
+        <p:spPr>
+          <a:xfrm>
+            <a:off x="804672" y="5129784"/>
+            <a:ext cx="6492240" cy="365760"/>
+          </a:xfrm>
+          <a:prstGeom prst="rect">
+            <a:avLst/>
+          </a:prstGeom>
+          <a:noFill/>
+          <a:ln/>
+        </p:spPr>
+        <p:txBody>
+          <a:bodyPr wrap="square" lIns="0" tIns="0" rIns="0" bIns="0" rtlCol="0" anchor="ctr"/>
+          <a:lstStyle/>
+          <a:p>
+            <a:pPr indent="0" marL="0">
+              <a:buNone/>
+            </a:pPr>
+            <a:r>
+              <a:rPr lang="en-US" sz="1500" b="1" dirty="0">
+                <a:solidFill>
+                  <a:srgbClr val="8CC63F"/>
+                </a:solidFill>
+                <a:latin typeface="Malgun Gothic" pitchFamily="34" charset="0"/>
+                <a:ea typeface="Malgun Gothic" pitchFamily="34" charset="-122"/>
+                <a:cs typeface="Malgun Gothic" pitchFamily="34" charset="-120"/>
+              </a:rPr>
+              <a:t>④ 커널 완료 — 결과는 전역 메모리에</a:t>
+            </a:r>
+            <a:endParaRPr lang="en-US" sz="1500" dirty="0"/>
+          </a:p>
+        </p:txBody>
+      </p:sp>
+      <p:sp>
+        <p:nvSpPr>
+          <p:cNvPr id="19" name="Text 17"/>
+          <p:cNvSpPr/>
+          <p:nvPr/>
+        </p:nvSpPr>
+        <p:spPr>
+          <a:xfrm>
+            <a:off x="804672" y="5477256"/>
+            <a:ext cx="6492240" cy="292608"/>
+          </a:xfrm>
+          <a:prstGeom prst="rect">
+            <a:avLst/>
+          </a:prstGeom>
+          <a:noFill/>
+          <a:ln/>
+        </p:spPr>
+        <p:txBody>
+          <a:bodyPr wrap="square" lIns="0" tIns="0" rIns="0" bIns="0" rtlCol="0" anchor="ctr"/>
+          <a:lstStyle/>
+          <a:p>
+            <a:pPr indent="0" marL="0">
+              <a:buNone/>
+            </a:pPr>
+            <a:r>
+              <a:rPr lang="en-US" sz="1150" dirty="0">
+                <a:solidFill>
+                  <a:srgbClr val="9AA6B2"/>
+                </a:solidFill>
+                <a:latin typeface="Courier New" pitchFamily="34" charset="0"/>
+                <a:ea typeface="Courier New" pitchFamily="34" charset="-122"/>
+                <a:cs typeface="Courier New" pitchFamily="34" charset="-120"/>
+              </a:rPr>
+              <a:t>호스트는 동기화 후 결과를 사용</a:t>
+            </a:r>
+            <a:endParaRPr lang="en-US" sz="1150" dirty="0"/>
+          </a:p>
+        </p:txBody>
+      </p:sp>
+      <p:sp>
+        <p:nvSpPr>
+          <p:cNvPr id="20" name="Text 18"/>
+          <p:cNvSpPr/>
+          <p:nvPr/>
+        </p:nvSpPr>
+        <p:spPr>
+          <a:xfrm>
+            <a:off x="4160520" y="2743200"/>
+            <a:ext cx="2743200" cy="274320"/>
+          </a:xfrm>
+          <a:prstGeom prst="rect">
+            <a:avLst/>
+          </a:prstGeom>
+          <a:noFill/>
+          <a:ln/>
+        </p:spPr>
+        <p:txBody>
+          <a:bodyPr wrap="square" lIns="0" tIns="0" rIns="0" bIns="0" rtlCol="0" anchor="ctr"/>
+          <a:lstStyle/>
+          <a:p>
+            <a:pPr indent="0" marL="0">
+              <a:buNone/>
+            </a:pPr>
+            <a:r>
+              <a:rPr lang="en-US" sz="1100" i="1" dirty="0">
+                <a:solidFill>
+                  <a:srgbClr val="9AA6B2"/>
+                </a:solidFill>
+                <a:latin typeface="Malgun Gothic" pitchFamily="34" charset="0"/>
+                <a:ea typeface="Malgun Gothic" pitchFamily="34" charset="-122"/>
+                <a:cs typeface="Malgun Gothic" pitchFamily="34" charset="-120"/>
+              </a:rPr>
+              <a:t>실행 구성 + 인자 전달</a:t>
+            </a:r>
+            <a:endParaRPr lang="en-US" sz="1100" dirty="0"/>
+          </a:p>
+        </p:txBody>
+      </p:sp>
+      <p:sp>
+        <p:nvSpPr>
+          <p:cNvPr id="21" name="Text 19"/>
+          <p:cNvSpPr/>
+          <p:nvPr/>
+        </p:nvSpPr>
+        <p:spPr>
+          <a:xfrm>
+            <a:off x="7635240" y="2103120"/>
+            <a:ext cx="822960" cy="365760"/>
+          </a:xfrm>
+          <a:prstGeom prst="rect">
+            <a:avLst/>
+          </a:prstGeom>
+          <a:noFill/>
+          <a:ln/>
+        </p:spPr>
+        <p:txBody>
+          <a:bodyPr wrap="square" lIns="0" tIns="0" rIns="0" bIns="0" rtlCol="0" anchor="ctr"/>
+          <a:lstStyle/>
+          <a:p>
+            <a:pPr indent="0" marL="0">
+              <a:buNone/>
+            </a:pPr>
+            <a:r>
+              <a:rPr lang="en-US" sz="1200" b="1" dirty="0">
+                <a:solidFill>
+                  <a:srgbClr val="4FB0C6"/>
+                </a:solidFill>
+                <a:latin typeface="Malgun Gothic" pitchFamily="34" charset="0"/>
+                <a:ea typeface="Malgun Gothic" pitchFamily="34" charset="-122"/>
+                <a:cs typeface="Malgun Gothic" pitchFamily="34" charset="-120"/>
+              </a:rPr>
+              <a:t>호스트</a:t>
+            </a:r>
+            <a:endParaRPr lang="en-US" sz="1200" dirty="0"/>
+          </a:p>
+        </p:txBody>
+      </p:sp>
+      <p:sp>
+        <p:nvSpPr>
+          <p:cNvPr id="22" name="Text 20"/>
+          <p:cNvSpPr/>
+          <p:nvPr/>
+        </p:nvSpPr>
+        <p:spPr>
+          <a:xfrm>
+            <a:off x="7635240" y="3200400"/>
+            <a:ext cx="1554480" cy="365760"/>
+          </a:xfrm>
+          <a:prstGeom prst="rect">
+            <a:avLst/>
+          </a:prstGeom>
+          <a:noFill/>
+          <a:ln/>
+        </p:spPr>
+        <p:txBody>
+          <a:bodyPr wrap="square" lIns="0" tIns="0" rIns="0" bIns="0" rtlCol="0" anchor="ctr"/>
+          <a:lstStyle/>
+          <a:p>
+            <a:pPr indent="0" marL="0">
+              <a:buNone/>
+            </a:pPr>
+            <a:r>
+              <a:rPr lang="en-US" sz="1200" b="1" dirty="0">
+                <a:solidFill>
+                  <a:srgbClr val="8CC63F"/>
+                </a:solidFill>
+                <a:latin typeface="Malgun Gothic" pitchFamily="34" charset="0"/>
+                <a:ea typeface="Malgun Gothic" pitchFamily="34" charset="-122"/>
+                <a:cs typeface="Malgun Gothic" pitchFamily="34" charset="-120"/>
+              </a:rPr>
+              <a:t>디바이스(GPU)</a:t>
+            </a:r>
+            <a:endParaRPr lang="en-US" sz="1200" dirty="0"/>
+          </a:p>
+        </p:txBody>
+      </p:sp>
+      <p:sp>
+        <p:nvSpPr>
+          <p:cNvPr id="23" name="Shape 21"/>
+          <p:cNvSpPr/>
+          <p:nvPr/>
+        </p:nvSpPr>
+        <p:spPr>
+          <a:xfrm>
+            <a:off x="9646920" y="1920240"/>
+            <a:ext cx="1965960" cy="3977640"/>
+          </a:xfrm>
+          <a:prstGeom prst="roundRect">
+            <a:avLst>
+              <a:gd name="adj" fmla="val 3256"/>
             </a:avLst>
           </a:prstGeom>
           <a:solidFill>
             <a:srgbClr val="1E232C"/>
           </a:solidFill>
-          <a:ln/>
-        </p:spPr>
-      </p:sp>
-      <p:sp>
-        <p:nvSpPr>
-          <p:cNvPr id="5" name="Text 3"/>
-          <p:cNvSpPr/>
-          <p:nvPr/>
-        </p:nvSpPr>
-        <p:spPr>
-          <a:xfrm>
-            <a:off x="804672" y="1755648"/>
-            <a:ext cx="1188720" cy="502920"/>
-          </a:xfrm>
-          <a:prstGeom prst="roundRect">
-            <a:avLst>
-              <a:gd name="adj" fmla="val 14545"/>
-            </a:avLst>
-          </a:prstGeom>
-          <a:solidFill>
-            <a:srgbClr val="8CC63F"/>
-          </a:solidFill>
-          <a:ln/>
-        </p:spPr>
-        <p:txBody>
-          <a:bodyPr wrap="square" rtlCol="0" anchor="ctr"/>
-          <a:lstStyle/>
-          <a:p>
-            <a:pPr algn="ctr" indent="0" marL="0">
+          <a:ln w="19050">
+            <a:solidFill>
+              <a:srgbClr val="E0A458"/>
+            </a:solidFill>
+            <a:prstDash val="solid"/>
+          </a:ln>
+        </p:spPr>
+      </p:sp>
+      <p:sp>
+        <p:nvSpPr>
+          <p:cNvPr id="24" name="Text 22"/>
+          <p:cNvSpPr/>
+          <p:nvPr/>
+        </p:nvSpPr>
+        <p:spPr>
+          <a:xfrm>
+            <a:off x="9875520" y="2103120"/>
+            <a:ext cx="1508760" cy="411480"/>
+          </a:xfrm>
+          <a:prstGeom prst="rect">
+            <a:avLst/>
+          </a:prstGeom>
+          <a:noFill/>
+          <a:ln/>
+        </p:spPr>
+        <p:txBody>
+          <a:bodyPr wrap="square" lIns="0" tIns="0" rIns="0" bIns="0" rtlCol="0" anchor="ctr"/>
+          <a:lstStyle/>
+          <a:p>
+            <a:pPr indent="0" marL="0">
               <a:buNone/>
             </a:pPr>
             <a:r>
               <a:rPr lang="en-US" sz="1700" b="1" dirty="0">
                 <a:solidFill>
-                  <a:srgbClr val="13161C"/>
-                </a:solidFill>
-                <a:latin typeface="Courier New" pitchFamily="34" charset="0"/>
-                <a:ea typeface="Courier New" pitchFamily="34" charset="-122"/>
-                <a:cs typeface="Courier New" pitchFamily="34" charset="-120"/>
-              </a:rPr>
-              <a:t>Ex 1</a:t>
+                  <a:srgbClr val="E0A458"/>
+                </a:solidFill>
+                <a:latin typeface="Malgun Gothic" pitchFamily="34" charset="0"/>
+                <a:ea typeface="Malgun Gothic" pitchFamily="34" charset="-122"/>
+                <a:cs typeface="Malgun Gothic" pitchFamily="34" charset="-120"/>
+              </a:rPr>
+              <a:t>비동기(async)</a:t>
             </a:r>
             <a:endParaRPr lang="en-US" sz="1700" dirty="0"/>
           </a:p>
@@ -3306,53 +4044,14 @@
       </p:sp>
       <p:sp>
         <p:nvSpPr>
-          <p:cNvPr id="6" name="Text 4"/>
-          <p:cNvSpPr/>
-          <p:nvPr/>
-        </p:nvSpPr>
-        <p:spPr>
-          <a:xfrm>
-            <a:off x="2148840" y="1773936"/>
-            <a:ext cx="3474720" cy="822960"/>
-          </a:xfrm>
-          <a:prstGeom prst="rect">
-            <a:avLst/>
-          </a:prstGeom>
-          <a:noFill/>
-          <a:ln/>
-        </p:spPr>
-        <p:txBody>
-          <a:bodyPr wrap="square" lIns="0" tIns="0" rIns="0" bIns="0" rtlCol="0" anchor="t"/>
-          <a:lstStyle/>
-          <a:p>
-            <a:pPr indent="0" marL="0">
-              <a:buNone/>
-            </a:pPr>
-            <a:r>
-              <a:rPr lang="en-US" sz="1700" b="1" dirty="0">
-                <a:solidFill>
-                  <a:srgbClr val="E8EDF2"/>
-                </a:solidFill>
-                <a:latin typeface="Malgun Gothic" pitchFamily="34" charset="0"/>
-                <a:ea typeface="Malgun Gothic" pitchFamily="34" charset="-122"/>
-                <a:cs typeface="Malgun Gothic" pitchFamily="34" charset="-120"/>
-              </a:rPr>
-              <a:t>스레드는 자기가 누구인지 안다</a:t>
-            </a:r>
-            <a:endParaRPr lang="en-US" sz="1700" dirty="0"/>
-          </a:p>
-        </p:txBody>
-      </p:sp>
-      <p:sp>
-        <p:nvSpPr>
-          <p:cNvPr id="7" name="Text 5"/>
-          <p:cNvSpPr/>
-          <p:nvPr/>
-        </p:nvSpPr>
-        <p:spPr>
-          <a:xfrm>
-            <a:off x="804672" y="2651760"/>
-            <a:ext cx="4791456" cy="731520"/>
+          <p:cNvPr id="25" name="Text 23"/>
+          <p:cNvSpPr/>
+          <p:nvPr/>
+        </p:nvSpPr>
+        <p:spPr>
+          <a:xfrm>
+            <a:off x="9875520" y="2651760"/>
+            <a:ext cx="1508760" cy="3063240"/>
           </a:xfrm>
           <a:prstGeom prst="rect">
             <a:avLst/>
@@ -3366,304 +4065,58 @@
           <a:p>
             <a:pPr indent="0" marL="0">
               <a:lnSpc>
-                <a:spcPct val="110000"/>
+                <a:spcPct val="115000"/>
               </a:lnSpc>
+              <a:spcAft>
+                <a:spcPts val="1000"/>
+              </a:spcAft>
               <a:buNone/>
             </a:pPr>
             <a:r>
               <a:rPr lang="en-US" sz="1400" dirty="0">
                 <a:solidFill>
-                  <a:srgbClr val="9AA6B2"/>
-                </a:solidFill>
-                <a:latin typeface="Malgun Gothic" pitchFamily="34" charset="0"/>
-                <a:ea typeface="Malgun Gothic" pitchFamily="34" charset="-122"/>
-                <a:cs typeface="Malgun Gothic" pitchFamily="34" charset="-120"/>
-              </a:rPr>
-              <a:t>커널 안에서 blockIdx.x를 printf로 출력해 확인</a:t>
+                  <a:srgbClr val="E8EDF2"/>
+                </a:solidFill>
+                <a:latin typeface="Malgun Gothic" pitchFamily="34" charset="0"/>
+                <a:ea typeface="Malgun Gothic" pitchFamily="34" charset="-122"/>
+                <a:cs typeface="Malgun Gothic" pitchFamily="34" charset="-120"/>
+              </a:rPr>
+              <a:t>호스트는 ① 요청 후 곧바로 다음 코드로 갑니다.</a:t>
             </a:r>
             <a:endParaRPr lang="en-US" sz="1400" dirty="0"/>
           </a:p>
-        </p:txBody>
-      </p:sp>
-      <p:sp>
-        <p:nvSpPr>
-          <p:cNvPr id="8" name="Shape 6"/>
-          <p:cNvSpPr/>
-          <p:nvPr/>
-        </p:nvSpPr>
-        <p:spPr>
-          <a:xfrm>
-            <a:off x="6309360" y="1554480"/>
-            <a:ext cx="5303520" cy="1965960"/>
-          </a:xfrm>
-          <a:prstGeom prst="roundRect">
-            <a:avLst>
-              <a:gd name="adj" fmla="val 3721"/>
-            </a:avLst>
-          </a:prstGeom>
-          <a:solidFill>
-            <a:srgbClr val="1E232C"/>
-          </a:solidFill>
-          <a:ln/>
-        </p:spPr>
-      </p:sp>
-      <p:sp>
-        <p:nvSpPr>
-          <p:cNvPr id="9" name="Text 7"/>
-          <p:cNvSpPr/>
-          <p:nvPr/>
-        </p:nvSpPr>
-        <p:spPr>
-          <a:xfrm>
-            <a:off x="6565392" y="1755648"/>
-            <a:ext cx="1188720" cy="502920"/>
-          </a:xfrm>
-          <a:prstGeom prst="roundRect">
-            <a:avLst>
-              <a:gd name="adj" fmla="val 14545"/>
-            </a:avLst>
-          </a:prstGeom>
-          <a:solidFill>
-            <a:srgbClr val="4FB0C6"/>
-          </a:solidFill>
-          <a:ln/>
-        </p:spPr>
-        <p:txBody>
-          <a:bodyPr wrap="square" rtlCol="0" anchor="ctr"/>
-          <a:lstStyle/>
-          <a:p>
-            <a:pPr algn="ctr" indent="0" marL="0">
-              <a:buNone/>
-            </a:pPr>
-            <a:r>
-              <a:rPr lang="en-US" sz="1700" b="1" dirty="0">
-                <a:solidFill>
-                  <a:srgbClr val="13161C"/>
-                </a:solidFill>
-                <a:latin typeface="Courier New" pitchFamily="34" charset="0"/>
-                <a:ea typeface="Courier New" pitchFamily="34" charset="-122"/>
-                <a:cs typeface="Courier New" pitchFamily="34" charset="-120"/>
-              </a:rPr>
-              <a:t>Ex 2</a:t>
-            </a:r>
-            <a:endParaRPr lang="en-US" sz="1700" dirty="0"/>
-          </a:p>
-        </p:txBody>
-      </p:sp>
-      <p:sp>
-        <p:nvSpPr>
-          <p:cNvPr id="10" name="Text 8"/>
-          <p:cNvSpPr/>
-          <p:nvPr/>
-        </p:nvSpPr>
-        <p:spPr>
-          <a:xfrm>
-            <a:off x="7909560" y="1773936"/>
-            <a:ext cx="3474720" cy="822960"/>
-          </a:xfrm>
-          <a:prstGeom prst="rect">
-            <a:avLst/>
-          </a:prstGeom>
-          <a:noFill/>
-          <a:ln/>
-        </p:spPr>
-        <p:txBody>
-          <a:bodyPr wrap="square" lIns="0" tIns="0" rIns="0" bIns="0" rtlCol="0" anchor="t"/>
-          <a:lstStyle/>
-          <a:p>
-            <a:pPr indent="0" marL="0">
-              <a:buNone/>
-            </a:pPr>
-            <a:r>
-              <a:rPr lang="en-US" sz="1700" b="1" dirty="0">
-                <a:solidFill>
-                  <a:srgbClr val="E8EDF2"/>
-                </a:solidFill>
-                <a:latin typeface="Malgun Gothic" pitchFamily="34" charset="0"/>
-                <a:ea typeface="Malgun Gothic" pitchFamily="34" charset="-122"/>
-                <a:cs typeface="Malgun Gothic" pitchFamily="34" charset="-120"/>
-              </a:rPr>
-              <a:t>그리드 크기를 바꿔보기</a:t>
-            </a:r>
-            <a:endParaRPr lang="en-US" sz="1700" dirty="0"/>
-          </a:p>
-        </p:txBody>
-      </p:sp>
-      <p:sp>
-        <p:nvSpPr>
-          <p:cNvPr id="11" name="Text 9"/>
-          <p:cNvSpPr/>
-          <p:nvPr/>
-        </p:nvSpPr>
-        <p:spPr>
-          <a:xfrm>
-            <a:off x="6565392" y="2651760"/>
-            <a:ext cx="4791456" cy="731520"/>
-          </a:xfrm>
-          <a:prstGeom prst="rect">
-            <a:avLst/>
-          </a:prstGeom>
-          <a:noFill/>
-          <a:ln/>
-        </p:spPr>
-        <p:txBody>
-          <a:bodyPr wrap="square" lIns="0" tIns="0" rIns="0" bIns="0" rtlCol="0" anchor="t"/>
-          <a:lstStyle/>
           <a:p>
             <a:pPr indent="0" marL="0">
               <a:lnSpc>
-                <a:spcPct val="110000"/>
+                <a:spcPct val="115000"/>
               </a:lnSpc>
+              <a:spcAft>
+                <a:spcPts val="1000"/>
+              </a:spcAft>
               <a:buNone/>
             </a:pPr>
             <a:r>
               <a:rPr lang="en-US" sz="1400" dirty="0">
                 <a:solidFill>
-                  <a:srgbClr val="9AA6B2"/>
-                </a:solidFill>
-                <a:latin typeface="Malgun Gothic" pitchFamily="34" charset="0"/>
-                <a:ea typeface="Malgun Gothic" pitchFamily="34" charset="-122"/>
-                <a:cs typeface="Malgun Gothic" pitchFamily="34" charset="-120"/>
-              </a:rPr>
-              <a:t>GRIDSIZE를 32/128/512로 바꿔 실행 시간 측정</a:t>
+                  <a:srgbClr val="E8EDF2"/>
+                </a:solidFill>
+                <a:latin typeface="Malgun Gothic" pitchFamily="34" charset="0"/>
+                <a:ea typeface="Malgun Gothic" pitchFamily="34" charset="-122"/>
+                <a:cs typeface="Malgun Gothic" pitchFamily="34" charset="-120"/>
+              </a:rPr>
+              <a:t>결과가 필요하면 cudaDeviceSynchronize로 GPU 완료를 기다립니다.</a:t>
             </a:r>
             <a:endParaRPr lang="en-US" sz="1400" dirty="0"/>
           </a:p>
-        </p:txBody>
-      </p:sp>
-      <p:sp>
-        <p:nvSpPr>
-          <p:cNvPr id="12" name="Shape 10"/>
-          <p:cNvSpPr/>
-          <p:nvPr/>
-        </p:nvSpPr>
-        <p:spPr>
-          <a:xfrm>
-            <a:off x="548640" y="3840480"/>
-            <a:ext cx="5303520" cy="1965960"/>
-          </a:xfrm>
-          <a:prstGeom prst="roundRect">
-            <a:avLst>
-              <a:gd name="adj" fmla="val 3721"/>
-            </a:avLst>
-          </a:prstGeom>
-          <a:solidFill>
-            <a:srgbClr val="1E232C"/>
-          </a:solidFill>
-          <a:ln/>
-        </p:spPr>
-      </p:sp>
-      <p:sp>
-        <p:nvSpPr>
-          <p:cNvPr id="13" name="Text 11"/>
-          <p:cNvSpPr/>
-          <p:nvPr/>
-        </p:nvSpPr>
-        <p:spPr>
-          <a:xfrm>
-            <a:off x="804672" y="4041648"/>
-            <a:ext cx="1188720" cy="502920"/>
-          </a:xfrm>
-          <a:prstGeom prst="roundRect">
-            <a:avLst>
-              <a:gd name="adj" fmla="val 14545"/>
-            </a:avLst>
-          </a:prstGeom>
-          <a:solidFill>
-            <a:srgbClr val="8CC63F"/>
-          </a:solidFill>
-          <a:ln/>
-        </p:spPr>
-        <p:txBody>
-          <a:bodyPr wrap="square" rtlCol="0" anchor="ctr"/>
-          <a:lstStyle/>
-          <a:p>
-            <a:pPr algn="ctr" indent="0" marL="0">
-              <a:buNone/>
-            </a:pPr>
-            <a:r>
-              <a:rPr lang="en-US" sz="1700" b="1" dirty="0">
-                <a:solidFill>
-                  <a:srgbClr val="13161C"/>
-                </a:solidFill>
-                <a:latin typeface="Courier New" pitchFamily="34" charset="0"/>
-                <a:ea typeface="Courier New" pitchFamily="34" charset="-122"/>
-                <a:cs typeface="Courier New" pitchFamily="34" charset="-120"/>
-              </a:rPr>
-              <a:t>Ex 3</a:t>
-            </a:r>
-            <a:endParaRPr lang="en-US" sz="1700" dirty="0"/>
-          </a:p>
-        </p:txBody>
-      </p:sp>
-      <p:sp>
-        <p:nvSpPr>
-          <p:cNvPr id="14" name="Text 12"/>
-          <p:cNvSpPr/>
-          <p:nvPr/>
-        </p:nvSpPr>
-        <p:spPr>
-          <a:xfrm>
-            <a:off x="2148840" y="4059936"/>
-            <a:ext cx="3474720" cy="822960"/>
-          </a:xfrm>
-          <a:prstGeom prst="rect">
-            <a:avLst/>
-          </a:prstGeom>
-          <a:noFill/>
-          <a:ln/>
-        </p:spPr>
-        <p:txBody>
-          <a:bodyPr wrap="square" lIns="0" tIns="0" rIns="0" bIns="0" rtlCol="0" anchor="t"/>
-          <a:lstStyle/>
-          <a:p>
-            <a:pPr indent="0" marL="0">
-              <a:buNone/>
-            </a:pPr>
-            <a:r>
-              <a:rPr lang="en-US" sz="1700" b="1" dirty="0">
-                <a:solidFill>
-                  <a:srgbClr val="E8EDF2"/>
-                </a:solidFill>
-                <a:latin typeface="Malgun Gothic" pitchFamily="34" charset="0"/>
-                <a:ea typeface="Malgun Gothic" pitchFamily="34" charset="-122"/>
-                <a:cs typeface="Malgun Gothic" pitchFamily="34" charset="-120"/>
-              </a:rPr>
-              <a:t>패턴을 내 마음대로</a:t>
-            </a:r>
-            <a:endParaRPr lang="en-US" sz="1700" dirty="0"/>
-          </a:p>
-        </p:txBody>
-      </p:sp>
-      <p:sp>
-        <p:nvSpPr>
-          <p:cNvPr id="15" name="Text 13"/>
-          <p:cNvSpPr/>
-          <p:nvPr/>
-        </p:nvSpPr>
-        <p:spPr>
-          <a:xfrm>
-            <a:off x="804672" y="4937760"/>
-            <a:ext cx="4791456" cy="731520"/>
-          </a:xfrm>
-          <a:prstGeom prst="rect">
-            <a:avLst/>
-          </a:prstGeom>
-          <a:noFill/>
-          <a:ln/>
-        </p:spPr>
-        <p:txBody>
-          <a:bodyPr wrap="square" lIns="0" tIns="0" rIns="0" bIns="0" rtlCol="0" anchor="t"/>
-          <a:lstStyle/>
           <a:p>
             <a:pPr indent="0" marL="0">
               <a:lnSpc>
-                <a:spcPct val="110000"/>
+                <a:spcPct val="115000"/>
               </a:lnSpc>
               <a:buNone/>
             </a:pPr>
             <a:r>
-              <a:rPr lang="en-US" sz="1400" dirty="0">
+              <a:rPr lang="en-US" sz="1400" i="1" dirty="0">
                 <a:solidFill>
                   <a:srgbClr val="9AA6B2"/>
                 </a:solidFill>
@@ -3671,7 +4124,7 @@
                 <a:ea typeface="Malgun Gothic" pitchFamily="34" charset="-122"/>
                 <a:cs typeface="Malgun Gothic" pitchFamily="34" charset="-120"/>
               </a:rPr>
-              <a:t>--pattern 0xDEADBEEF 로 커널 인자 전달 관찰</a:t>
+              <a:t>→ 이 비동기 특성은 세션 3(타이밍)·세션 4(오류)에서 자세히.</a:t>
             </a:r>
             <a:endParaRPr lang="en-US" sz="1400" dirty="0"/>
           </a:p>
@@ -3679,137 +4132,30 @@
       </p:sp>
       <p:sp>
         <p:nvSpPr>
-          <p:cNvPr id="16" name="Shape 14"/>
-          <p:cNvSpPr/>
-          <p:nvPr/>
-        </p:nvSpPr>
-        <p:spPr>
-          <a:xfrm>
-            <a:off x="6309360" y="3840480"/>
-            <a:ext cx="5303520" cy="1965960"/>
-          </a:xfrm>
-          <a:prstGeom prst="roundRect">
-            <a:avLst>
-              <a:gd name="adj" fmla="val 3721"/>
-            </a:avLst>
-          </a:prstGeom>
-          <a:solidFill>
-            <a:srgbClr val="1E232C"/>
-          </a:solidFill>
-          <a:ln/>
-        </p:spPr>
-      </p:sp>
-      <p:sp>
-        <p:nvSpPr>
-          <p:cNvPr id="17" name="Text 15"/>
-          <p:cNvSpPr/>
-          <p:nvPr/>
-        </p:nvSpPr>
-        <p:spPr>
-          <a:xfrm>
-            <a:off x="6565392" y="4041648"/>
-            <a:ext cx="1188720" cy="502920"/>
-          </a:xfrm>
-          <a:prstGeom prst="roundRect">
-            <a:avLst>
-              <a:gd name="adj" fmla="val 14545"/>
-            </a:avLst>
-          </a:prstGeom>
-          <a:solidFill>
-            <a:srgbClr val="E0A458"/>
-          </a:solidFill>
-          <a:ln/>
-        </p:spPr>
-        <p:txBody>
-          <a:bodyPr wrap="square" rtlCol="0" anchor="ctr"/>
+          <p:cNvPr id="26" name="Text 24"/>
+          <p:cNvSpPr/>
+          <p:nvPr/>
+        </p:nvSpPr>
+        <p:spPr>
+          <a:xfrm>
+            <a:off x="548640" y="6035040"/>
+            <a:ext cx="11064240" cy="365760"/>
+          </a:xfrm>
+          <a:prstGeom prst="rect">
+            <a:avLst/>
+          </a:prstGeom>
+          <a:noFill/>
+          <a:ln/>
+        </p:spPr>
+        <p:txBody>
+          <a:bodyPr wrap="square" lIns="0" tIns="0" rIns="0" bIns="0" rtlCol="0" anchor="ctr"/>
           <a:lstStyle/>
           <a:p>
             <a:pPr algn="ctr" indent="0" marL="0">
               <a:buNone/>
             </a:pPr>
             <a:r>
-              <a:rPr lang="en-US" sz="1700" b="1" dirty="0">
-                <a:solidFill>
-                  <a:srgbClr val="13161C"/>
-                </a:solidFill>
-                <a:latin typeface="Courier New" pitchFamily="34" charset="0"/>
-                <a:ea typeface="Courier New" pitchFamily="34" charset="-122"/>
-                <a:cs typeface="Courier New" pitchFamily="34" charset="-120"/>
-              </a:rPr>
-              <a:t>Ex 4</a:t>
-            </a:r>
-            <a:endParaRPr lang="en-US" sz="1700" dirty="0"/>
-          </a:p>
-        </p:txBody>
-      </p:sp>
-      <p:sp>
-        <p:nvSpPr>
-          <p:cNvPr id="18" name="Text 16"/>
-          <p:cNvSpPr/>
-          <p:nvPr/>
-        </p:nvSpPr>
-        <p:spPr>
-          <a:xfrm>
-            <a:off x="7909560" y="4059936"/>
-            <a:ext cx="3474720" cy="822960"/>
-          </a:xfrm>
-          <a:prstGeom prst="rect">
-            <a:avLst/>
-          </a:prstGeom>
-          <a:noFill/>
-          <a:ln/>
-        </p:spPr>
-        <p:txBody>
-          <a:bodyPr wrap="square" lIns="0" tIns="0" rIns="0" bIns="0" rtlCol="0" anchor="t"/>
-          <a:lstStyle/>
-          <a:p>
-            <a:pPr indent="0" marL="0">
-              <a:buNone/>
-            </a:pPr>
-            <a:r>
-              <a:rPr lang="en-US" sz="1700" b="1" dirty="0">
-                <a:solidFill>
-                  <a:srgbClr val="E8EDF2"/>
-                </a:solidFill>
-                <a:latin typeface="Malgun Gothic" pitchFamily="34" charset="0"/>
-                <a:ea typeface="Malgun Gothic" pitchFamily="34" charset="-122"/>
-                <a:cs typeface="Malgun Gothic" pitchFamily="34" charset="-120"/>
-              </a:rPr>
-              <a:t>경계 검사를 지우면?</a:t>
-            </a:r>
-            <a:endParaRPr lang="en-US" sz="1700" dirty="0"/>
-          </a:p>
-        </p:txBody>
-      </p:sp>
-      <p:sp>
-        <p:nvSpPr>
-          <p:cNvPr id="19" name="Text 17"/>
-          <p:cNvSpPr/>
-          <p:nvPr/>
-        </p:nvSpPr>
-        <p:spPr>
-          <a:xfrm>
-            <a:off x="6565392" y="4937760"/>
-            <a:ext cx="4791456" cy="731520"/>
-          </a:xfrm>
-          <a:prstGeom prst="rect">
-            <a:avLst/>
-          </a:prstGeom>
-          <a:noFill/>
-          <a:ln/>
-        </p:spPr>
-        <p:txBody>
-          <a:bodyPr wrap="square" lIns="0" tIns="0" rIns="0" bIns="0" rtlCol="0" anchor="t"/>
-          <a:lstStyle/>
-          <a:p>
-            <a:pPr indent="0" marL="0">
-              <a:lnSpc>
-                <a:spcPct val="110000"/>
-              </a:lnSpc>
-              <a:buNone/>
-            </a:pPr>
-            <a:r>
-              <a:rPr lang="en-US" sz="1400" dirty="0">
+              <a:rPr lang="en-US" sz="1300" i="1" dirty="0">
                 <a:solidFill>
                   <a:srgbClr val="9AA6B2"/>
                 </a:solidFill>
@@ -3817,9 +4163,9 @@
                 <a:ea typeface="Malgun Gothic" pitchFamily="34" charset="-122"/>
                 <a:cs typeface="Malgun Gothic" pitchFamily="34" charset="-120"/>
               </a:rPr>
-              <a:t>guard를 없애 illegal memory access 재현</a:t>
-            </a:r>
-            <a:endParaRPr lang="en-US" sz="1400" dirty="0"/>
+              <a:t>이 저장소: 스레드가 blockIdx로 자기 1 MB를 맡아 순회 (세션 1의 첫 커널이 바로 이 흐름으로 실행됩니다).</a:t>
+            </a:r>
+            <a:endParaRPr lang="en-US" sz="1300" dirty="0"/>
           </a:p>
         </p:txBody>
       </p:sp>
@@ -3892,7 +4238,7 @@
                 <a:ea typeface="Courier New" pitchFamily="34" charset="-122"/>
                 <a:cs typeface="Courier New" pitchFamily="34" charset="-120"/>
               </a:rPr>
-              <a:t>11</a:t>
+              <a:t>10</a:t>
             </a:r>
             <a:endParaRPr lang="en-US" sz="2200" dirty="0"/>
           </a:p>
@@ -3931,7 +4277,7 @@
                 <a:ea typeface="Malgun Gothic" pitchFamily="34" charset="-122"/>
                 <a:cs typeface="Malgun Gothic" pitchFamily="34" charset="-120"/>
               </a:rPr>
-              <a:t>핵심 정리 &amp; 자주 하는 실수</a:t>
+              <a:t>실습 미리보기 · Lab 1</a:t>
             </a:r>
             <a:endParaRPr lang="en-US" sz="3000" dirty="0"/>
           </a:p>
@@ -3945,12 +4291,12 @@
         </p:nvSpPr>
         <p:spPr>
           <a:xfrm>
-            <a:off x="548640" y="1600200"/>
-            <a:ext cx="5349240" cy="4114800"/>
+            <a:off x="548640" y="1554480"/>
+            <a:ext cx="5303520" cy="1965960"/>
           </a:xfrm>
           <a:prstGeom prst="roundRect">
             <a:avLst>
-              <a:gd name="adj" fmla="val 1778"/>
+              <a:gd name="adj" fmla="val 3721"/>
             </a:avLst>
           </a:prstGeom>
           <a:solidFill>
@@ -3967,154 +4313,136 @@
         </p:nvSpPr>
         <p:spPr>
           <a:xfrm>
-            <a:off x="822960" y="1828800"/>
-            <a:ext cx="4800600" cy="457200"/>
-          </a:xfrm>
-          <a:prstGeom prst="rect">
-            <a:avLst/>
-          </a:prstGeom>
-          <a:noFill/>
-          <a:ln/>
-        </p:spPr>
-        <p:txBody>
-          <a:bodyPr wrap="square" lIns="0" tIns="0" rIns="0" bIns="0" rtlCol="0" anchor="ctr"/>
-          <a:lstStyle/>
-          <a:p>
-            <a:pPr indent="0" marL="0">
-              <a:buNone/>
-            </a:pPr>
-            <a:r>
-              <a:rPr lang="en-US" sz="2000" b="1" dirty="0">
-                <a:solidFill>
-                  <a:srgbClr val="8CC63F"/>
-                </a:solidFill>
-                <a:latin typeface="Malgun Gothic" pitchFamily="34" charset="0"/>
-                <a:ea typeface="Malgun Gothic" pitchFamily="34" charset="-122"/>
-                <a:cs typeface="Malgun Gothic" pitchFamily="34" charset="-120"/>
-              </a:rPr>
-              <a:t>기억할 것</a:t>
-            </a:r>
-            <a:endParaRPr lang="en-US" sz="2000" dirty="0"/>
-          </a:p>
-        </p:txBody>
-      </p:sp>
-      <p:sp>
-        <p:nvSpPr>
-          <p:cNvPr id="6" name="Text 4"/>
-          <p:cNvSpPr/>
-          <p:nvPr/>
-        </p:nvSpPr>
-        <p:spPr>
-          <a:xfrm>
-            <a:off x="822960" y="2423160"/>
-            <a:ext cx="4800600" cy="3108960"/>
-          </a:xfrm>
-          <a:prstGeom prst="rect">
-            <a:avLst/>
-          </a:prstGeom>
-          <a:noFill/>
-          <a:ln/>
-        </p:spPr>
-        <p:txBody>
-          <a:bodyPr wrap="square" lIns="0" tIns="0" rIns="0" bIns="0" rtlCol="0" anchor="t"/>
-          <a:lstStyle/>
-          <a:p>
-            <a:pPr marL="342900" indent="-342900">
-              <a:spcAft>
-                <a:spcPts val="1200"/>
-              </a:spcAft>
-              <a:buSzPct val="100000"/>
-              <a:buChar char="✓"/>
-            </a:pPr>
-            <a:r>
-              <a:rPr lang="en-US" sz="1600" dirty="0">
-                <a:solidFill>
-                  <a:srgbClr val="E8EDF2"/>
-                </a:solidFill>
-                <a:latin typeface="Malgun Gothic" pitchFamily="34" charset="0"/>
-                <a:ea typeface="Malgun Gothic" pitchFamily="34" charset="-122"/>
-                <a:cs typeface="Malgun Gothic" pitchFamily="34" charset="-120"/>
-              </a:rPr>
-              <a:t>커널 = __global__, 반환형 void</a:t>
-            </a:r>
-            <a:endParaRPr lang="en-US" sz="1600" dirty="0"/>
-          </a:p>
-          <a:p>
-            <a:pPr marL="342900" indent="-342900">
-              <a:spcAft>
-                <a:spcPts val="1200"/>
-              </a:spcAft>
-              <a:buSzPct val="100000"/>
-              <a:buChar char="✓"/>
-            </a:pPr>
-            <a:r>
-              <a:rPr lang="en-US" sz="1600" dirty="0">
-                <a:solidFill>
-                  <a:srgbClr val="E8EDF2"/>
-                </a:solidFill>
-                <a:latin typeface="Malgun Gothic" pitchFamily="34" charset="0"/>
-                <a:ea typeface="Malgun Gothic" pitchFamily="34" charset="-122"/>
-                <a:cs typeface="Malgun Gothic" pitchFamily="34" charset="-120"/>
-              </a:rPr>
-              <a:t>&lt;&lt;&lt;블록수, 블록당스레드수&gt;&gt;&gt;</a:t>
-            </a:r>
-            <a:endParaRPr lang="en-US" sz="1600" dirty="0"/>
-          </a:p>
-          <a:p>
-            <a:pPr marL="342900" indent="-342900">
-              <a:spcAft>
-                <a:spcPts val="1200"/>
-              </a:spcAft>
-              <a:buSzPct val="100000"/>
-              <a:buChar char="✓"/>
-            </a:pPr>
-            <a:r>
-              <a:rPr lang="en-US" sz="1600" dirty="0">
-                <a:solidFill>
-                  <a:srgbClr val="E8EDF2"/>
-                </a:solidFill>
-                <a:latin typeface="Malgun Gothic" pitchFamily="34" charset="0"/>
-                <a:ea typeface="Malgun Gothic" pitchFamily="34" charset="-122"/>
-                <a:cs typeface="Malgun Gothic" pitchFamily="34" charset="-120"/>
-              </a:rPr>
-              <a:t>blockIdx로 자기 구역 계산</a:t>
-            </a:r>
-            <a:endParaRPr lang="en-US" sz="1600" dirty="0"/>
-          </a:p>
-          <a:p>
-            <a:pPr marL="342900" indent="-342900">
-              <a:buSzPct val="100000"/>
-              <a:buChar char="✓"/>
-            </a:pPr>
-            <a:r>
-              <a:rPr lang="en-US" sz="1600" dirty="0">
-                <a:solidFill>
-                  <a:srgbClr val="E8EDF2"/>
-                </a:solidFill>
-                <a:latin typeface="Malgun Gothic" pitchFamily="34" charset="0"/>
-                <a:ea typeface="Malgun Gothic" pitchFamily="34" charset="-122"/>
-                <a:cs typeface="Malgun Gothic" pitchFamily="34" charset="-120"/>
-              </a:rPr>
-              <a:t>경계 검사(guard)는 필수</a:t>
-            </a:r>
-            <a:endParaRPr lang="en-US" sz="1600" dirty="0"/>
-          </a:p>
-        </p:txBody>
-      </p:sp>
-      <p:sp>
-        <p:nvSpPr>
-          <p:cNvPr id="7" name="Shape 5"/>
-          <p:cNvSpPr/>
-          <p:nvPr/>
-        </p:nvSpPr>
-        <p:spPr>
-          <a:xfrm>
-            <a:off x="6263640" y="1600200"/>
-            <a:ext cx="5349240" cy="4114800"/>
+            <a:off x="804672" y="1755648"/>
+            <a:ext cx="1188720" cy="502920"/>
           </a:xfrm>
           <a:prstGeom prst="roundRect">
             <a:avLst>
-              <a:gd name="adj" fmla="val 1778"/>
+              <a:gd name="adj" fmla="val 14545"/>
+            </a:avLst>
+          </a:prstGeom>
+          <a:solidFill>
+            <a:srgbClr val="8CC63F"/>
+          </a:solidFill>
+          <a:ln/>
+        </p:spPr>
+        <p:txBody>
+          <a:bodyPr wrap="square" rtlCol="0" anchor="ctr"/>
+          <a:lstStyle/>
+          <a:p>
+            <a:pPr algn="ctr" indent="0" marL="0">
+              <a:buNone/>
+            </a:pPr>
+            <a:r>
+              <a:rPr lang="en-US" sz="1700" b="1" dirty="0">
+                <a:solidFill>
+                  <a:srgbClr val="13161C"/>
+                </a:solidFill>
+                <a:latin typeface="Courier New" pitchFamily="34" charset="0"/>
+                <a:ea typeface="Courier New" pitchFamily="34" charset="-122"/>
+                <a:cs typeface="Courier New" pitchFamily="34" charset="-120"/>
+              </a:rPr>
+              <a:t>Ex 1</a:t>
+            </a:r>
+            <a:endParaRPr lang="en-US" sz="1700" dirty="0"/>
+          </a:p>
+        </p:txBody>
+      </p:sp>
+      <p:sp>
+        <p:nvSpPr>
+          <p:cNvPr id="6" name="Text 4"/>
+          <p:cNvSpPr/>
+          <p:nvPr/>
+        </p:nvSpPr>
+        <p:spPr>
+          <a:xfrm>
+            <a:off x="2148840" y="1773936"/>
+            <a:ext cx="3474720" cy="822960"/>
+          </a:xfrm>
+          <a:prstGeom prst="rect">
+            <a:avLst/>
+          </a:prstGeom>
+          <a:noFill/>
+          <a:ln/>
+        </p:spPr>
+        <p:txBody>
+          <a:bodyPr wrap="square" lIns="0" tIns="0" rIns="0" bIns="0" rtlCol="0" anchor="t"/>
+          <a:lstStyle/>
+          <a:p>
+            <a:pPr indent="0" marL="0">
+              <a:buNone/>
+            </a:pPr>
+            <a:r>
+              <a:rPr lang="en-US" sz="1700" b="1" dirty="0">
+                <a:solidFill>
+                  <a:srgbClr val="E8EDF2"/>
+                </a:solidFill>
+                <a:latin typeface="Malgun Gothic" pitchFamily="34" charset="0"/>
+                <a:ea typeface="Malgun Gothic" pitchFamily="34" charset="-122"/>
+                <a:cs typeface="Malgun Gothic" pitchFamily="34" charset="-120"/>
+              </a:rPr>
+              <a:t>스레드는 자기가 누구인지 안다</a:t>
+            </a:r>
+            <a:endParaRPr lang="en-US" sz="1700" dirty="0"/>
+          </a:p>
+        </p:txBody>
+      </p:sp>
+      <p:sp>
+        <p:nvSpPr>
+          <p:cNvPr id="7" name="Text 5"/>
+          <p:cNvSpPr/>
+          <p:nvPr/>
+        </p:nvSpPr>
+        <p:spPr>
+          <a:xfrm>
+            <a:off x="804672" y="2651760"/>
+            <a:ext cx="4791456" cy="731520"/>
+          </a:xfrm>
+          <a:prstGeom prst="rect">
+            <a:avLst/>
+          </a:prstGeom>
+          <a:noFill/>
+          <a:ln/>
+        </p:spPr>
+        <p:txBody>
+          <a:bodyPr wrap="square" lIns="0" tIns="0" rIns="0" bIns="0" rtlCol="0" anchor="t"/>
+          <a:lstStyle/>
+          <a:p>
+            <a:pPr indent="0" marL="0">
+              <a:lnSpc>
+                <a:spcPct val="110000"/>
+              </a:lnSpc>
+              <a:buNone/>
+            </a:pPr>
+            <a:r>
+              <a:rPr lang="en-US" sz="1400" dirty="0">
+                <a:solidFill>
+                  <a:srgbClr val="9AA6B2"/>
+                </a:solidFill>
+                <a:latin typeface="Malgun Gothic" pitchFamily="34" charset="0"/>
+                <a:ea typeface="Malgun Gothic" pitchFamily="34" charset="-122"/>
+                <a:cs typeface="Malgun Gothic" pitchFamily="34" charset="-120"/>
+              </a:rPr>
+              <a:t>커널 안에서 blockIdx.x를 printf로 출력해 확인</a:t>
+            </a:r>
+            <a:endParaRPr lang="en-US" sz="1400" dirty="0"/>
+          </a:p>
+        </p:txBody>
+      </p:sp>
+      <p:sp>
+        <p:nvSpPr>
+          <p:cNvPr id="8" name="Shape 6"/>
+          <p:cNvSpPr/>
+          <p:nvPr/>
+        </p:nvSpPr>
+        <p:spPr>
+          <a:xfrm>
+            <a:off x="6309360" y="1554480"/>
+            <a:ext cx="5303520" cy="1965960"/>
+          </a:xfrm>
+          <a:prstGeom prst="roundRect">
+            <a:avLst>
+              <a:gd name="adj" fmla="val 3721"/>
             </a:avLst>
           </a:prstGeom>
           <a:solidFill>
@@ -4125,53 +4453,96 @@
       </p:sp>
       <p:sp>
         <p:nvSpPr>
-          <p:cNvPr id="8" name="Text 6"/>
-          <p:cNvSpPr/>
-          <p:nvPr/>
-        </p:nvSpPr>
-        <p:spPr>
-          <a:xfrm>
-            <a:off x="6537960" y="1828800"/>
-            <a:ext cx="4800600" cy="457200"/>
-          </a:xfrm>
-          <a:prstGeom prst="rect">
-            <a:avLst/>
-          </a:prstGeom>
-          <a:noFill/>
-          <a:ln/>
-        </p:spPr>
-        <p:txBody>
-          <a:bodyPr wrap="square" lIns="0" tIns="0" rIns="0" bIns="0" rtlCol="0" anchor="ctr"/>
+          <p:cNvPr id="9" name="Text 7"/>
+          <p:cNvSpPr/>
+          <p:nvPr/>
+        </p:nvSpPr>
+        <p:spPr>
+          <a:xfrm>
+            <a:off x="6565392" y="1755648"/>
+            <a:ext cx="1188720" cy="502920"/>
+          </a:xfrm>
+          <a:prstGeom prst="roundRect">
+            <a:avLst>
+              <a:gd name="adj" fmla="val 14545"/>
+            </a:avLst>
+          </a:prstGeom>
+          <a:solidFill>
+            <a:srgbClr val="4FB0C6"/>
+          </a:solidFill>
+          <a:ln/>
+        </p:spPr>
+        <p:txBody>
+          <a:bodyPr wrap="square" rtlCol="0" anchor="ctr"/>
+          <a:lstStyle/>
+          <a:p>
+            <a:pPr algn="ctr" indent="0" marL="0">
+              <a:buNone/>
+            </a:pPr>
+            <a:r>
+              <a:rPr lang="en-US" sz="1700" b="1" dirty="0">
+                <a:solidFill>
+                  <a:srgbClr val="13161C"/>
+                </a:solidFill>
+                <a:latin typeface="Courier New" pitchFamily="34" charset="0"/>
+                <a:ea typeface="Courier New" pitchFamily="34" charset="-122"/>
+                <a:cs typeface="Courier New" pitchFamily="34" charset="-120"/>
+              </a:rPr>
+              <a:t>Ex 2</a:t>
+            </a:r>
+            <a:endParaRPr lang="en-US" sz="1700" dirty="0"/>
+          </a:p>
+        </p:txBody>
+      </p:sp>
+      <p:sp>
+        <p:nvSpPr>
+          <p:cNvPr id="10" name="Text 8"/>
+          <p:cNvSpPr/>
+          <p:nvPr/>
+        </p:nvSpPr>
+        <p:spPr>
+          <a:xfrm>
+            <a:off x="7909560" y="1773936"/>
+            <a:ext cx="3474720" cy="822960"/>
+          </a:xfrm>
+          <a:prstGeom prst="rect">
+            <a:avLst/>
+          </a:prstGeom>
+          <a:noFill/>
+          <a:ln/>
+        </p:spPr>
+        <p:txBody>
+          <a:bodyPr wrap="square" lIns="0" tIns="0" rIns="0" bIns="0" rtlCol="0" anchor="t"/>
           <a:lstStyle/>
           <a:p>
             <a:pPr indent="0" marL="0">
               <a:buNone/>
             </a:pPr>
             <a:r>
-              <a:rPr lang="en-US" sz="2000" b="1" dirty="0">
-                <a:solidFill>
-                  <a:srgbClr val="E0A458"/>
-                </a:solidFill>
-                <a:latin typeface="Malgun Gothic" pitchFamily="34" charset="0"/>
-                <a:ea typeface="Malgun Gothic" pitchFamily="34" charset="-122"/>
-                <a:cs typeface="Malgun Gothic" pitchFamily="34" charset="-120"/>
-              </a:rPr>
-              <a:t>입문자 함정</a:t>
-            </a:r>
-            <a:endParaRPr lang="en-US" sz="2000" dirty="0"/>
-          </a:p>
-        </p:txBody>
-      </p:sp>
-      <p:sp>
-        <p:nvSpPr>
-          <p:cNvPr id="9" name="Text 7"/>
-          <p:cNvSpPr/>
-          <p:nvPr/>
-        </p:nvSpPr>
-        <p:spPr>
-          <a:xfrm>
-            <a:off x="6537960" y="2423160"/>
-            <a:ext cx="4800600" cy="3108960"/>
+              <a:rPr lang="en-US" sz="1700" b="1" dirty="0">
+                <a:solidFill>
+                  <a:srgbClr val="E8EDF2"/>
+                </a:solidFill>
+                <a:latin typeface="Malgun Gothic" pitchFamily="34" charset="0"/>
+                <a:ea typeface="Malgun Gothic" pitchFamily="34" charset="-122"/>
+                <a:cs typeface="Malgun Gothic" pitchFamily="34" charset="-120"/>
+              </a:rPr>
+              <a:t>그리드 크기를 바꿔보기</a:t>
+            </a:r>
+            <a:endParaRPr lang="en-US" sz="1700" dirty="0"/>
+          </a:p>
+        </p:txBody>
+      </p:sp>
+      <p:sp>
+        <p:nvSpPr>
+          <p:cNvPr id="11" name="Text 9"/>
+          <p:cNvSpPr/>
+          <p:nvPr/>
+        </p:nvSpPr>
+        <p:spPr>
+          <a:xfrm>
+            <a:off x="6565392" y="2651760"/>
+            <a:ext cx="4791456" cy="731520"/>
           </a:xfrm>
           <a:prstGeom prst="rect">
             <a:avLst/>
@@ -4183,15 +4554,118 @@
           <a:bodyPr wrap="square" lIns="0" tIns="0" rIns="0" bIns="0" rtlCol="0" anchor="t"/>
           <a:lstStyle/>
           <a:p>
-            <a:pPr marL="342900" indent="-342900">
-              <a:spcAft>
-                <a:spcPts val="1200"/>
-              </a:spcAft>
-              <a:buSzPct val="100000"/>
-              <a:buChar char="✗"/>
-            </a:pPr>
-            <a:r>
-              <a:rPr lang="en-US" sz="1600" dirty="0">
+            <a:pPr indent="0" marL="0">
+              <a:lnSpc>
+                <a:spcPct val="110000"/>
+              </a:lnSpc>
+              <a:buNone/>
+            </a:pPr>
+            <a:r>
+              <a:rPr lang="en-US" sz="1400" dirty="0">
+                <a:solidFill>
+                  <a:srgbClr val="9AA6B2"/>
+                </a:solidFill>
+                <a:latin typeface="Malgun Gothic" pitchFamily="34" charset="0"/>
+                <a:ea typeface="Malgun Gothic" pitchFamily="34" charset="-122"/>
+                <a:cs typeface="Malgun Gothic" pitchFamily="34" charset="-120"/>
+              </a:rPr>
+              <a:t>GRIDSIZE를 32/128/512로 바꿔 실행 시간 측정</a:t>
+            </a:r>
+            <a:endParaRPr lang="en-US" sz="1400" dirty="0"/>
+          </a:p>
+        </p:txBody>
+      </p:sp>
+      <p:sp>
+        <p:nvSpPr>
+          <p:cNvPr id="12" name="Shape 10"/>
+          <p:cNvSpPr/>
+          <p:nvPr/>
+        </p:nvSpPr>
+        <p:spPr>
+          <a:xfrm>
+            <a:off x="548640" y="3840480"/>
+            <a:ext cx="5303520" cy="1965960"/>
+          </a:xfrm>
+          <a:prstGeom prst="roundRect">
+            <a:avLst>
+              <a:gd name="adj" fmla="val 3721"/>
+            </a:avLst>
+          </a:prstGeom>
+          <a:solidFill>
+            <a:srgbClr val="1E232C"/>
+          </a:solidFill>
+          <a:ln/>
+        </p:spPr>
+      </p:sp>
+      <p:sp>
+        <p:nvSpPr>
+          <p:cNvPr id="13" name="Text 11"/>
+          <p:cNvSpPr/>
+          <p:nvPr/>
+        </p:nvSpPr>
+        <p:spPr>
+          <a:xfrm>
+            <a:off x="804672" y="4041648"/>
+            <a:ext cx="1188720" cy="502920"/>
+          </a:xfrm>
+          <a:prstGeom prst="roundRect">
+            <a:avLst>
+              <a:gd name="adj" fmla="val 14545"/>
+            </a:avLst>
+          </a:prstGeom>
+          <a:solidFill>
+            <a:srgbClr val="8CC63F"/>
+          </a:solidFill>
+          <a:ln/>
+        </p:spPr>
+        <p:txBody>
+          <a:bodyPr wrap="square" rtlCol="0" anchor="ctr"/>
+          <a:lstStyle/>
+          <a:p>
+            <a:pPr algn="ctr" indent="0" marL="0">
+              <a:buNone/>
+            </a:pPr>
+            <a:r>
+              <a:rPr lang="en-US" sz="1700" b="1" dirty="0">
+                <a:solidFill>
+                  <a:srgbClr val="13161C"/>
+                </a:solidFill>
+                <a:latin typeface="Courier New" pitchFamily="34" charset="0"/>
+                <a:ea typeface="Courier New" pitchFamily="34" charset="-122"/>
+                <a:cs typeface="Courier New" pitchFamily="34" charset="-120"/>
+              </a:rPr>
+              <a:t>Ex 3</a:t>
+            </a:r>
+            <a:endParaRPr lang="en-US" sz="1700" dirty="0"/>
+          </a:p>
+        </p:txBody>
+      </p:sp>
+      <p:sp>
+        <p:nvSpPr>
+          <p:cNvPr id="14" name="Text 12"/>
+          <p:cNvSpPr/>
+          <p:nvPr/>
+        </p:nvSpPr>
+        <p:spPr>
+          <a:xfrm>
+            <a:off x="2148840" y="4059936"/>
+            <a:ext cx="3474720" cy="822960"/>
+          </a:xfrm>
+          <a:prstGeom prst="rect">
+            <a:avLst/>
+          </a:prstGeom>
+          <a:noFill/>
+          <a:ln/>
+        </p:spPr>
+        <p:txBody>
+          <a:bodyPr wrap="square" lIns="0" tIns="0" rIns="0" bIns="0" rtlCol="0" anchor="t"/>
+          <a:lstStyle/>
+          <a:p>
+            <a:pPr indent="0" marL="0">
+              <a:buNone/>
+            </a:pPr>
+            <a:r>
+              <a:rPr lang="en-US" sz="1700" b="1" dirty="0">
                 <a:solidFill>
                   <a:srgbClr val="E8EDF2"/>
                 </a:solidFill>
@@ -4199,20 +4673,145 @@
                 <a:ea typeface="Malgun Gothic" pitchFamily="34" charset="-122"/>
                 <a:cs typeface="Malgun Gothic" pitchFamily="34" charset="-120"/>
               </a:rPr>
-              <a:t>커널을 일반 함수처럼 () 로 호출 → &lt;&lt;&lt;&gt;&gt;&gt; 필수</a:t>
-            </a:r>
-            <a:endParaRPr lang="en-US" sz="1600" dirty="0"/>
-          </a:p>
-          <a:p>
-            <a:pPr marL="342900" indent="-342900">
-              <a:spcAft>
-                <a:spcPts val="1200"/>
-              </a:spcAft>
-              <a:buSzPct val="100000"/>
-              <a:buChar char="✗"/>
-            </a:pPr>
-            <a:r>
-              <a:rPr lang="en-US" sz="1600" dirty="0">
+              <a:t>패턴을 내 마음대로</a:t>
+            </a:r>
+            <a:endParaRPr lang="en-US" sz="1700" dirty="0"/>
+          </a:p>
+        </p:txBody>
+      </p:sp>
+      <p:sp>
+        <p:nvSpPr>
+          <p:cNvPr id="15" name="Text 13"/>
+          <p:cNvSpPr/>
+          <p:nvPr/>
+        </p:nvSpPr>
+        <p:spPr>
+          <a:xfrm>
+            <a:off x="804672" y="4937760"/>
+            <a:ext cx="4791456" cy="731520"/>
+          </a:xfrm>
+          <a:prstGeom prst="rect">
+            <a:avLst/>
+          </a:prstGeom>
+          <a:noFill/>
+          <a:ln/>
+        </p:spPr>
+        <p:txBody>
+          <a:bodyPr wrap="square" lIns="0" tIns="0" rIns="0" bIns="0" rtlCol="0" anchor="t"/>
+          <a:lstStyle/>
+          <a:p>
+            <a:pPr indent="0" marL="0">
+              <a:lnSpc>
+                <a:spcPct val="110000"/>
+              </a:lnSpc>
+              <a:buNone/>
+            </a:pPr>
+            <a:r>
+              <a:rPr lang="en-US" sz="1400" dirty="0">
+                <a:solidFill>
+                  <a:srgbClr val="9AA6B2"/>
+                </a:solidFill>
+                <a:latin typeface="Malgun Gothic" pitchFamily="34" charset="0"/>
+                <a:ea typeface="Malgun Gothic" pitchFamily="34" charset="-122"/>
+                <a:cs typeface="Malgun Gothic" pitchFamily="34" charset="-120"/>
+              </a:rPr>
+              <a:t>--pattern 0xDEADBEEF 로 커널 인자 전달 관찰</a:t>
+            </a:r>
+            <a:endParaRPr lang="en-US" sz="1400" dirty="0"/>
+          </a:p>
+        </p:txBody>
+      </p:sp>
+      <p:sp>
+        <p:nvSpPr>
+          <p:cNvPr id="16" name="Shape 14"/>
+          <p:cNvSpPr/>
+          <p:nvPr/>
+        </p:nvSpPr>
+        <p:spPr>
+          <a:xfrm>
+            <a:off x="6309360" y="3840480"/>
+            <a:ext cx="5303520" cy="1965960"/>
+          </a:xfrm>
+          <a:prstGeom prst="roundRect">
+            <a:avLst>
+              <a:gd name="adj" fmla="val 3721"/>
+            </a:avLst>
+          </a:prstGeom>
+          <a:solidFill>
+            <a:srgbClr val="1E232C"/>
+          </a:solidFill>
+          <a:ln/>
+        </p:spPr>
+      </p:sp>
+      <p:sp>
+        <p:nvSpPr>
+          <p:cNvPr id="17" name="Text 15"/>
+          <p:cNvSpPr/>
+          <p:nvPr/>
+        </p:nvSpPr>
+        <p:spPr>
+          <a:xfrm>
+            <a:off x="6565392" y="4041648"/>
+            <a:ext cx="1188720" cy="502920"/>
+          </a:xfrm>
+          <a:prstGeom prst="roundRect">
+            <a:avLst>
+              <a:gd name="adj" fmla="val 14545"/>
+            </a:avLst>
+          </a:prstGeom>
+          <a:solidFill>
+            <a:srgbClr val="E0A458"/>
+          </a:solidFill>
+          <a:ln/>
+        </p:spPr>
+        <p:txBody>
+          <a:bodyPr wrap="square" rtlCol="0" anchor="ctr"/>
+          <a:lstStyle/>
+          <a:p>
+            <a:pPr algn="ctr" indent="0" marL="0">
+              <a:buNone/>
+            </a:pPr>
+            <a:r>
+              <a:rPr lang="en-US" sz="1700" b="1" dirty="0">
+                <a:solidFill>
+                  <a:srgbClr val="13161C"/>
+                </a:solidFill>
+                <a:latin typeface="Courier New" pitchFamily="34" charset="0"/>
+                <a:ea typeface="Courier New" pitchFamily="34" charset="-122"/>
+                <a:cs typeface="Courier New" pitchFamily="34" charset="-120"/>
+              </a:rPr>
+              <a:t>Ex 4</a:t>
+            </a:r>
+            <a:endParaRPr lang="en-US" sz="1700" dirty="0"/>
+          </a:p>
+        </p:txBody>
+      </p:sp>
+      <p:sp>
+        <p:nvSpPr>
+          <p:cNvPr id="18" name="Text 16"/>
+          <p:cNvSpPr/>
+          <p:nvPr/>
+        </p:nvSpPr>
+        <p:spPr>
+          <a:xfrm>
+            <a:off x="7909560" y="4059936"/>
+            <a:ext cx="3474720" cy="822960"/>
+          </a:xfrm>
+          <a:prstGeom prst="rect">
+            <a:avLst/>
+          </a:prstGeom>
+          <a:noFill/>
+          <a:ln/>
+        </p:spPr>
+        <p:txBody>
+          <a:bodyPr wrap="square" lIns="0" tIns="0" rIns="0" bIns="0" rtlCol="0" anchor="t"/>
+          <a:lstStyle/>
+          <a:p>
+            <a:pPr indent="0" marL="0">
+              <a:buNone/>
+            </a:pPr>
+            <a:r>
+              <a:rPr lang="en-US" sz="1700" b="1" dirty="0">
                 <a:solidFill>
                   <a:srgbClr val="E8EDF2"/>
                 </a:solidFill>
@@ -4220,48 +4819,51 @@
                 <a:ea typeface="Malgun Gothic" pitchFamily="34" charset="-122"/>
                 <a:cs typeface="Malgun Gothic" pitchFamily="34" charset="-120"/>
               </a:rPr>
-              <a:t>커널에서 값을 return 하려 함 → void, 결과는 메모리로</a:t>
-            </a:r>
-            <a:endParaRPr lang="en-US" sz="1600" dirty="0"/>
-          </a:p>
-          <a:p>
-            <a:pPr marL="342900" indent="-342900">
-              <a:spcAft>
-                <a:spcPts val="1200"/>
-              </a:spcAft>
-              <a:buSzPct val="100000"/>
-              <a:buChar char="✗"/>
-            </a:pPr>
-            <a:r>
-              <a:rPr lang="en-US" sz="1600" dirty="0">
-                <a:solidFill>
-                  <a:srgbClr val="E8EDF2"/>
-                </a:solidFill>
-                <a:latin typeface="Malgun Gothic" pitchFamily="34" charset="0"/>
-                <a:ea typeface="Malgun Gothic" pitchFamily="34" charset="-122"/>
-                <a:cs typeface="Malgun Gothic" pitchFamily="34" charset="-120"/>
-              </a:rPr>
-              <a:t>경계 검사 생략 → 이웃 메모리 침범</a:t>
-            </a:r>
-            <a:endParaRPr lang="en-US" sz="1600" dirty="0"/>
-          </a:p>
-          <a:p>
-            <a:pPr marL="342900" indent="-342900">
-              <a:buSzPct val="100000"/>
-              <a:buChar char="✗"/>
-            </a:pPr>
-            <a:r>
-              <a:rPr lang="en-US" sz="1600" dirty="0">
-                <a:solidFill>
-                  <a:srgbClr val="E8EDF2"/>
-                </a:solidFill>
-                <a:latin typeface="Malgun Gothic" pitchFamily="34" charset="0"/>
-                <a:ea typeface="Malgun Gothic" pitchFamily="34" charset="-122"/>
-                <a:cs typeface="Malgun Gothic" pitchFamily="34" charset="-120"/>
-              </a:rPr>
-              <a:t>호스트 포인터를 커널에 그대로 전달 → 디바이스 포인터여야</a:t>
-            </a:r>
-            <a:endParaRPr lang="en-US" sz="1600" dirty="0"/>
+              <a:t>경계 검사를 지우면?</a:t>
+            </a:r>
+            <a:endParaRPr lang="en-US" sz="1700" dirty="0"/>
+          </a:p>
+        </p:txBody>
+      </p:sp>
+      <p:sp>
+        <p:nvSpPr>
+          <p:cNvPr id="19" name="Text 17"/>
+          <p:cNvSpPr/>
+          <p:nvPr/>
+        </p:nvSpPr>
+        <p:spPr>
+          <a:xfrm>
+            <a:off x="6565392" y="4937760"/>
+            <a:ext cx="4791456" cy="731520"/>
+          </a:xfrm>
+          <a:prstGeom prst="rect">
+            <a:avLst/>
+          </a:prstGeom>
+          <a:noFill/>
+          <a:ln/>
+        </p:spPr>
+        <p:txBody>
+          <a:bodyPr wrap="square" lIns="0" tIns="0" rIns="0" bIns="0" rtlCol="0" anchor="t"/>
+          <a:lstStyle/>
+          <a:p>
+            <a:pPr indent="0" marL="0">
+              <a:lnSpc>
+                <a:spcPct val="110000"/>
+              </a:lnSpc>
+              <a:buNone/>
+            </a:pPr>
+            <a:r>
+              <a:rPr lang="en-US" sz="1400" dirty="0">
+                <a:solidFill>
+                  <a:srgbClr val="9AA6B2"/>
+                </a:solidFill>
+                <a:latin typeface="Malgun Gothic" pitchFamily="34" charset="0"/>
+                <a:ea typeface="Malgun Gothic" pitchFamily="34" charset="-122"/>
+                <a:cs typeface="Malgun Gothic" pitchFamily="34" charset="-120"/>
+              </a:rPr>
+              <a:t>guard를 없애 illegal memory access 재현</a:t>
+            </a:r>
+            <a:endParaRPr lang="en-US" sz="1400" dirty="0"/>
           </a:p>
         </p:txBody>
       </p:sp>
@@ -4276,6 +4878,448 @@
 <file path=ppt/slides/slide14.xml><?xml version="1.0" encoding="utf-8"?>
 <p:sld xmlns:a="http://schemas.openxmlformats.org/drawingml/2006/main" xmlns:r="http://schemas.openxmlformats.org/officeDocument/2006/relationships" xmlns:p="http://schemas.openxmlformats.org/presentationml/2006/main">
   <p:cSld name="Slide 14">
+    <p:bg>
+      <p:bgPr>
+        <a:solidFill>
+          <a:srgbClr val="13161C"/>
+        </a:solidFill>
+      </p:bgPr>
+    </p:bg>
+    <p:spTree>
+      <p:nvGrpSpPr>
+        <p:cNvPr id="1" name=""/>
+        <p:cNvGrpSpPr/>
+        <p:nvPr/>
+      </p:nvGrpSpPr>
+      <p:grpSpPr>
+        <a:xfrm>
+          <a:off x="0" y="0"/>
+          <a:ext cx="0" cy="0"/>
+          <a:chOff x="0" y="0"/>
+          <a:chExt cx="0" cy="0"/>
+        </a:xfrm>
+      </p:grpSpPr>
+      <p:sp>
+        <p:nvSpPr>
+          <p:cNvPr id="2" name="Text 0"/>
+          <p:cNvSpPr/>
+          <p:nvPr/>
+        </p:nvSpPr>
+        <p:spPr>
+          <a:xfrm>
+            <a:off x="548640" y="411480"/>
+            <a:ext cx="640080" cy="640080"/>
+          </a:xfrm>
+          <a:prstGeom prst="roundRect">
+            <a:avLst>
+              <a:gd name="adj" fmla="val 12857"/>
+            </a:avLst>
+          </a:prstGeom>
+          <a:solidFill>
+            <a:srgbClr val="8CC63F"/>
+          </a:solidFill>
+          <a:ln/>
+        </p:spPr>
+        <p:txBody>
+          <a:bodyPr wrap="square" rtlCol="0" anchor="ctr"/>
+          <a:lstStyle/>
+          <a:p>
+            <a:pPr algn="ctr" indent="0" marL="0">
+              <a:buNone/>
+            </a:pPr>
+            <a:r>
+              <a:rPr lang="en-US" sz="2200" b="1" dirty="0">
+                <a:solidFill>
+                  <a:srgbClr val="13161C"/>
+                </a:solidFill>
+                <a:latin typeface="Courier New" pitchFamily="34" charset="0"/>
+                <a:ea typeface="Courier New" pitchFamily="34" charset="-122"/>
+                <a:cs typeface="Courier New" pitchFamily="34" charset="-120"/>
+              </a:rPr>
+              <a:t>11</a:t>
+            </a:r>
+            <a:endParaRPr lang="en-US" sz="2200" dirty="0"/>
+          </a:p>
+        </p:txBody>
+      </p:sp>
+      <p:sp>
+        <p:nvSpPr>
+          <p:cNvPr id="3" name="Text 1"/>
+          <p:cNvSpPr/>
+          <p:nvPr/>
+        </p:nvSpPr>
+        <p:spPr>
+          <a:xfrm>
+            <a:off x="1325880" y="384048"/>
+            <a:ext cx="10287000" cy="694944"/>
+          </a:xfrm>
+          <a:prstGeom prst="rect">
+            <a:avLst/>
+          </a:prstGeom>
+          <a:noFill/>
+          <a:ln/>
+        </p:spPr>
+        <p:txBody>
+          <a:bodyPr wrap="square" lIns="0" tIns="0" rIns="0" bIns="0" rtlCol="0" anchor="ctr"/>
+          <a:lstStyle/>
+          <a:p>
+            <a:pPr algn="l" indent="0" marL="0">
+              <a:buNone/>
+            </a:pPr>
+            <a:r>
+              <a:rPr lang="en-US" sz="3000" b="1" dirty="0">
+                <a:solidFill>
+                  <a:srgbClr val="E8EDF2"/>
+                </a:solidFill>
+                <a:latin typeface="Malgun Gothic" pitchFamily="34" charset="0"/>
+                <a:ea typeface="Malgun Gothic" pitchFamily="34" charset="-122"/>
+                <a:cs typeface="Malgun Gothic" pitchFamily="34" charset="-120"/>
+              </a:rPr>
+              <a:t>핵심 정리 &amp; 자주 하는 실수</a:t>
+            </a:r>
+            <a:endParaRPr lang="en-US" sz="3000" dirty="0"/>
+          </a:p>
+        </p:txBody>
+      </p:sp>
+      <p:sp>
+        <p:nvSpPr>
+          <p:cNvPr id="4" name="Shape 2"/>
+          <p:cNvSpPr/>
+          <p:nvPr/>
+        </p:nvSpPr>
+        <p:spPr>
+          <a:xfrm>
+            <a:off x="548640" y="1600200"/>
+            <a:ext cx="5349240" cy="4114800"/>
+          </a:xfrm>
+          <a:prstGeom prst="roundRect">
+            <a:avLst>
+              <a:gd name="adj" fmla="val 1778"/>
+            </a:avLst>
+          </a:prstGeom>
+          <a:solidFill>
+            <a:srgbClr val="1E232C"/>
+          </a:solidFill>
+          <a:ln/>
+        </p:spPr>
+      </p:sp>
+      <p:sp>
+        <p:nvSpPr>
+          <p:cNvPr id="5" name="Text 3"/>
+          <p:cNvSpPr/>
+          <p:nvPr/>
+        </p:nvSpPr>
+        <p:spPr>
+          <a:xfrm>
+            <a:off x="822960" y="1828800"/>
+            <a:ext cx="4800600" cy="457200"/>
+          </a:xfrm>
+          <a:prstGeom prst="rect">
+            <a:avLst/>
+          </a:prstGeom>
+          <a:noFill/>
+          <a:ln/>
+        </p:spPr>
+        <p:txBody>
+          <a:bodyPr wrap="square" lIns="0" tIns="0" rIns="0" bIns="0" rtlCol="0" anchor="ctr"/>
+          <a:lstStyle/>
+          <a:p>
+            <a:pPr indent="0" marL="0">
+              <a:buNone/>
+            </a:pPr>
+            <a:r>
+              <a:rPr lang="en-US" sz="2000" b="1" dirty="0">
+                <a:solidFill>
+                  <a:srgbClr val="8CC63F"/>
+                </a:solidFill>
+                <a:latin typeface="Malgun Gothic" pitchFamily="34" charset="0"/>
+                <a:ea typeface="Malgun Gothic" pitchFamily="34" charset="-122"/>
+                <a:cs typeface="Malgun Gothic" pitchFamily="34" charset="-120"/>
+              </a:rPr>
+              <a:t>기억할 것</a:t>
+            </a:r>
+            <a:endParaRPr lang="en-US" sz="2000" dirty="0"/>
+          </a:p>
+        </p:txBody>
+      </p:sp>
+      <p:sp>
+        <p:nvSpPr>
+          <p:cNvPr id="6" name="Text 4"/>
+          <p:cNvSpPr/>
+          <p:nvPr/>
+        </p:nvSpPr>
+        <p:spPr>
+          <a:xfrm>
+            <a:off x="822960" y="2423160"/>
+            <a:ext cx="4800600" cy="3108960"/>
+          </a:xfrm>
+          <a:prstGeom prst="rect">
+            <a:avLst/>
+          </a:prstGeom>
+          <a:noFill/>
+          <a:ln/>
+        </p:spPr>
+        <p:txBody>
+          <a:bodyPr wrap="square" lIns="0" tIns="0" rIns="0" bIns="0" rtlCol="0" anchor="t"/>
+          <a:lstStyle/>
+          <a:p>
+            <a:pPr marL="342900" indent="-342900">
+              <a:spcAft>
+                <a:spcPts val="1200"/>
+              </a:spcAft>
+              <a:buSzPct val="100000"/>
+              <a:buChar char="✓"/>
+            </a:pPr>
+            <a:r>
+              <a:rPr lang="en-US" sz="1600" dirty="0">
+                <a:solidFill>
+                  <a:srgbClr val="E8EDF2"/>
+                </a:solidFill>
+                <a:latin typeface="Malgun Gothic" pitchFamily="34" charset="0"/>
+                <a:ea typeface="Malgun Gothic" pitchFamily="34" charset="-122"/>
+                <a:cs typeface="Malgun Gothic" pitchFamily="34" charset="-120"/>
+              </a:rPr>
+              <a:t>커널 = __global__, 반환형 void</a:t>
+            </a:r>
+            <a:endParaRPr lang="en-US" sz="1600" dirty="0"/>
+          </a:p>
+          <a:p>
+            <a:pPr marL="342900" indent="-342900">
+              <a:spcAft>
+                <a:spcPts val="1200"/>
+              </a:spcAft>
+              <a:buSzPct val="100000"/>
+              <a:buChar char="✓"/>
+            </a:pPr>
+            <a:r>
+              <a:rPr lang="en-US" sz="1600" dirty="0">
+                <a:solidFill>
+                  <a:srgbClr val="E8EDF2"/>
+                </a:solidFill>
+                <a:latin typeface="Malgun Gothic" pitchFamily="34" charset="0"/>
+                <a:ea typeface="Malgun Gothic" pitchFamily="34" charset="-122"/>
+                <a:cs typeface="Malgun Gothic" pitchFamily="34" charset="-120"/>
+              </a:rPr>
+              <a:t>&lt;&lt;&lt;블록수, 블록당스레드수&gt;&gt;&gt;</a:t>
+            </a:r>
+            <a:endParaRPr lang="en-US" sz="1600" dirty="0"/>
+          </a:p>
+          <a:p>
+            <a:pPr marL="342900" indent="-342900">
+              <a:spcAft>
+                <a:spcPts val="1200"/>
+              </a:spcAft>
+              <a:buSzPct val="100000"/>
+              <a:buChar char="✓"/>
+            </a:pPr>
+            <a:r>
+              <a:rPr lang="en-US" sz="1600" dirty="0">
+                <a:solidFill>
+                  <a:srgbClr val="E8EDF2"/>
+                </a:solidFill>
+                <a:latin typeface="Malgun Gothic" pitchFamily="34" charset="0"/>
+                <a:ea typeface="Malgun Gothic" pitchFamily="34" charset="-122"/>
+                <a:cs typeface="Malgun Gothic" pitchFamily="34" charset="-120"/>
+              </a:rPr>
+              <a:t>blockIdx로 자기 구역 계산</a:t>
+            </a:r>
+            <a:endParaRPr lang="en-US" sz="1600" dirty="0"/>
+          </a:p>
+          <a:p>
+            <a:pPr marL="342900" indent="-342900">
+              <a:buSzPct val="100000"/>
+              <a:buChar char="✓"/>
+            </a:pPr>
+            <a:r>
+              <a:rPr lang="en-US" sz="1600" dirty="0">
+                <a:solidFill>
+                  <a:srgbClr val="E8EDF2"/>
+                </a:solidFill>
+                <a:latin typeface="Malgun Gothic" pitchFamily="34" charset="0"/>
+                <a:ea typeface="Malgun Gothic" pitchFamily="34" charset="-122"/>
+                <a:cs typeface="Malgun Gothic" pitchFamily="34" charset="-120"/>
+              </a:rPr>
+              <a:t>경계 검사(guard)는 필수</a:t>
+            </a:r>
+            <a:endParaRPr lang="en-US" sz="1600" dirty="0"/>
+          </a:p>
+        </p:txBody>
+      </p:sp>
+      <p:sp>
+        <p:nvSpPr>
+          <p:cNvPr id="7" name="Shape 5"/>
+          <p:cNvSpPr/>
+          <p:nvPr/>
+        </p:nvSpPr>
+        <p:spPr>
+          <a:xfrm>
+            <a:off x="6263640" y="1600200"/>
+            <a:ext cx="5349240" cy="4114800"/>
+          </a:xfrm>
+          <a:prstGeom prst="roundRect">
+            <a:avLst>
+              <a:gd name="adj" fmla="val 1778"/>
+            </a:avLst>
+          </a:prstGeom>
+          <a:solidFill>
+            <a:srgbClr val="1E232C"/>
+          </a:solidFill>
+          <a:ln/>
+        </p:spPr>
+      </p:sp>
+      <p:sp>
+        <p:nvSpPr>
+          <p:cNvPr id="8" name="Text 6"/>
+          <p:cNvSpPr/>
+          <p:nvPr/>
+        </p:nvSpPr>
+        <p:spPr>
+          <a:xfrm>
+            <a:off x="6537960" y="1828800"/>
+            <a:ext cx="4800600" cy="457200"/>
+          </a:xfrm>
+          <a:prstGeom prst="rect">
+            <a:avLst/>
+          </a:prstGeom>
+          <a:noFill/>
+          <a:ln/>
+        </p:spPr>
+        <p:txBody>
+          <a:bodyPr wrap="square" lIns="0" tIns="0" rIns="0" bIns="0" rtlCol="0" anchor="ctr"/>
+          <a:lstStyle/>
+          <a:p>
+            <a:pPr indent="0" marL="0">
+              <a:buNone/>
+            </a:pPr>
+            <a:r>
+              <a:rPr lang="en-US" sz="2000" b="1" dirty="0">
+                <a:solidFill>
+                  <a:srgbClr val="E0A458"/>
+                </a:solidFill>
+                <a:latin typeface="Malgun Gothic" pitchFamily="34" charset="0"/>
+                <a:ea typeface="Malgun Gothic" pitchFamily="34" charset="-122"/>
+                <a:cs typeface="Malgun Gothic" pitchFamily="34" charset="-120"/>
+              </a:rPr>
+              <a:t>입문자 함정</a:t>
+            </a:r>
+            <a:endParaRPr lang="en-US" sz="2000" dirty="0"/>
+          </a:p>
+        </p:txBody>
+      </p:sp>
+      <p:sp>
+        <p:nvSpPr>
+          <p:cNvPr id="9" name="Text 7"/>
+          <p:cNvSpPr/>
+          <p:nvPr/>
+        </p:nvSpPr>
+        <p:spPr>
+          <a:xfrm>
+            <a:off x="6537960" y="2423160"/>
+            <a:ext cx="4800600" cy="3108960"/>
+          </a:xfrm>
+          <a:prstGeom prst="rect">
+            <a:avLst/>
+          </a:prstGeom>
+          <a:noFill/>
+          <a:ln/>
+        </p:spPr>
+        <p:txBody>
+          <a:bodyPr wrap="square" lIns="0" tIns="0" rIns="0" bIns="0" rtlCol="0" anchor="t"/>
+          <a:lstStyle/>
+          <a:p>
+            <a:pPr marL="342900" indent="-342900">
+              <a:spcAft>
+                <a:spcPts val="1200"/>
+              </a:spcAft>
+              <a:buSzPct val="100000"/>
+              <a:buChar char="✗"/>
+            </a:pPr>
+            <a:r>
+              <a:rPr lang="en-US" sz="1600" dirty="0">
+                <a:solidFill>
+                  <a:srgbClr val="E8EDF2"/>
+                </a:solidFill>
+                <a:latin typeface="Malgun Gothic" pitchFamily="34" charset="0"/>
+                <a:ea typeface="Malgun Gothic" pitchFamily="34" charset="-122"/>
+                <a:cs typeface="Malgun Gothic" pitchFamily="34" charset="-120"/>
+              </a:rPr>
+              <a:t>커널을 일반 함수처럼 () 로 호출 → &lt;&lt;&lt;&gt;&gt;&gt; 필수</a:t>
+            </a:r>
+            <a:endParaRPr lang="en-US" sz="1600" dirty="0"/>
+          </a:p>
+          <a:p>
+            <a:pPr marL="342900" indent="-342900">
+              <a:spcAft>
+                <a:spcPts val="1200"/>
+              </a:spcAft>
+              <a:buSzPct val="100000"/>
+              <a:buChar char="✗"/>
+            </a:pPr>
+            <a:r>
+              <a:rPr lang="en-US" sz="1600" dirty="0">
+                <a:solidFill>
+                  <a:srgbClr val="E8EDF2"/>
+                </a:solidFill>
+                <a:latin typeface="Malgun Gothic" pitchFamily="34" charset="0"/>
+                <a:ea typeface="Malgun Gothic" pitchFamily="34" charset="-122"/>
+                <a:cs typeface="Malgun Gothic" pitchFamily="34" charset="-120"/>
+              </a:rPr>
+              <a:t>커널에서 값을 return 하려 함 → void, 결과는 메모리로</a:t>
+            </a:r>
+            <a:endParaRPr lang="en-US" sz="1600" dirty="0"/>
+          </a:p>
+          <a:p>
+            <a:pPr marL="342900" indent="-342900">
+              <a:spcAft>
+                <a:spcPts val="1200"/>
+              </a:spcAft>
+              <a:buSzPct val="100000"/>
+              <a:buChar char="✗"/>
+            </a:pPr>
+            <a:r>
+              <a:rPr lang="en-US" sz="1600" dirty="0">
+                <a:solidFill>
+                  <a:srgbClr val="E8EDF2"/>
+                </a:solidFill>
+                <a:latin typeface="Malgun Gothic" pitchFamily="34" charset="0"/>
+                <a:ea typeface="Malgun Gothic" pitchFamily="34" charset="-122"/>
+                <a:cs typeface="Malgun Gothic" pitchFamily="34" charset="-120"/>
+              </a:rPr>
+              <a:t>경계 검사 생략 → 이웃 메모리 침범</a:t>
+            </a:r>
+            <a:endParaRPr lang="en-US" sz="1600" dirty="0"/>
+          </a:p>
+          <a:p>
+            <a:pPr marL="342900" indent="-342900">
+              <a:buSzPct val="100000"/>
+              <a:buChar char="✗"/>
+            </a:pPr>
+            <a:r>
+              <a:rPr lang="en-US" sz="1600" dirty="0">
+                <a:solidFill>
+                  <a:srgbClr val="E8EDF2"/>
+                </a:solidFill>
+                <a:latin typeface="Malgun Gothic" pitchFamily="34" charset="0"/>
+                <a:ea typeface="Malgun Gothic" pitchFamily="34" charset="-122"/>
+                <a:cs typeface="Malgun Gothic" pitchFamily="34" charset="-120"/>
+              </a:rPr>
+              <a:t>호스트 포인터를 커널에 그대로 전달 → 디바이스 포인터여야</a:t>
+            </a:r>
+            <a:endParaRPr lang="en-US" sz="1600" dirty="0"/>
+          </a:p>
+        </p:txBody>
+      </p:sp>
+    </p:spTree>
+  </p:cSld>
+  <p:clrMapOvr>
+    <a:masterClrMapping/>
+  </p:clrMapOvr>
+</p:sld>
+</file>
+
+<file path=ppt/slides/slide15.xml><?xml version="1.0" encoding="utf-8"?>
+<p:sld xmlns:a="http://schemas.openxmlformats.org/drawingml/2006/main" xmlns:r="http://schemas.openxmlformats.org/officeDocument/2006/relationships" xmlns:p="http://schemas.openxmlformats.org/presentationml/2006/main">
+  <p:cSld name="Slide 15">
     <p:bg>
       <p:bgPr>
         <a:solidFill>

</xml_diff>